<commit_message>
feat(ia-pep-2): regeneration S01 au nouveau format
</commit_message>
<xml_diff>
--- a/ia-pep-2/seance-01/presentation.pptx
+++ b/ia-pep-2/seance-01/presentation.pptx
@@ -17,6 +17,9 @@
     <p:sldId id="265" r:id="rId16"/>
     <p:sldId id="266" r:id="rId17"/>
     <p:sldId id="267" r:id="rId18"/>
+    <p:sldId id="268" r:id="rId19"/>
+    <p:sldId id="269" r:id="rId20"/>
+    <p:sldId id="270" r:id="rId21"/>
   </p:sldIdLst>
   <p:sldSz cx="12191695" cy="6858000" type="screen4x3"/>
   <p:notesSz cx="6858000" cy="9144000"/>
@@ -3115,7 +3118,50 @@
         </p:nvSpPr>
         <p:spPr>
           <a:xfrm>
-            <a:off x="822960" y="1920240"/>
+            <a:off x="822960" y="1828800"/>
+            <a:ext cx="10515600" cy="1828800"/>
+          </a:xfrm>
+          <a:prstGeom prst="rect">
+            <a:avLst/>
+          </a:prstGeom>
+          <a:noFill/>
+        </p:spPr>
+        <p:txBody>
+          <a:bodyPr wrap="square">
+            <a:spAutoFit/>
+          </a:bodyPr>
+          <a:lstStyle/>
+          <a:p>
+            <a:r>
+              <a:rPr sz="4000" b="1">
+                <a:solidFill>
+                  <a:srgbClr val="FFFFFF"/>
+                </a:solidFill>
+              </a:rPr>
+              <a:t>Séance 01 — Qu'est-ce que l'IA ? Introduction et démystification</a:t>
+            </a:r>
+          </a:p>
+          <a:p>
+            <a:r>
+              <a:rPr sz="2000">
+                <a:solidFill>
+                  <a:srgbClr val="ECEFF1"/>
+                </a:solidFill>
+              </a:rPr>
+              <a:t>What is AI? Introduction and demystification</a:t>
+            </a:r>
+          </a:p>
+        </p:txBody>
+      </p:sp>
+      <p:sp>
+        <p:nvSpPr>
+          <p:cNvPr id="3" name="TextBox 2"/>
+          <p:cNvSpPr txBox="1"/>
+          <p:nvPr/>
+        </p:nvSpPr>
+        <p:spPr>
+          <a:xfrm>
+            <a:off x="822960" y="4023360"/>
             <a:ext cx="10515600" cy="1463040"/>
           </a:xfrm>
           <a:prstGeom prst="rect">
@@ -3130,144 +3176,13 @@
           <a:lstStyle/>
           <a:p>
             <a:r>
-              <a:rPr sz="4000" b="1" i="0">
-                <a:solidFill>
-                  <a:srgbClr val="FFFFFF"/>
+              <a:rPr sz="1500">
+                <a:solidFill>
+                  <a:srgbClr val="ECEFF1"/>
                 </a:solidFill>
               </a:rPr>
-              <a:t>🤖 Séance 01 — Introduction à l'Intelligence Artificielle</a:t>
-            </a:r>
-          </a:p>
-        </p:txBody>
-      </p:sp>
-      <p:sp>
-        <p:nvSpPr>
-          <p:cNvPr id="3" name="TextBox 2"/>
-          <p:cNvSpPr txBox="1"/>
-          <p:nvPr/>
-        </p:nvSpPr>
-        <p:spPr>
-          <a:xfrm>
-            <a:off x="822960" y="3566160"/>
-            <a:ext cx="10515600" cy="548640"/>
-          </a:xfrm>
-          <a:prstGeom prst="rect">
-            <a:avLst/>
-          </a:prstGeom>
-          <a:noFill/>
-        </p:spPr>
-        <p:txBody>
-          <a:bodyPr wrap="square">
-            <a:spAutoFit/>
-          </a:bodyPr>
-          <a:lstStyle/>
-          <a:p>
-            <a:r>
-              <a:rPr sz="1800" b="0" i="1">
-                <a:solidFill>
-                  <a:srgbClr val="ECEFF1"/>
-                </a:solidFill>
-              </a:rPr>
-              <a:t>Introduction to Artificial Intelligence</a:t>
-            </a:r>
-          </a:p>
-        </p:txBody>
-      </p:sp>
-      <p:sp>
-        <p:nvSpPr>
-          <p:cNvPr id="4" name="TextBox 3"/>
-          <p:cNvSpPr txBox="1"/>
-          <p:nvPr/>
-        </p:nvSpPr>
-        <p:spPr>
-          <a:xfrm>
-            <a:off x="822960" y="4114800"/>
-            <a:ext cx="10515600" cy="548640"/>
-          </a:xfrm>
-          <a:prstGeom prst="rect">
-            <a:avLst/>
-          </a:prstGeom>
-          <a:noFill/>
-        </p:spPr>
-        <p:txBody>
-          <a:bodyPr wrap="square">
-            <a:spAutoFit/>
-          </a:bodyPr>
-          <a:lstStyle/>
-          <a:p>
-            <a:r>
-              <a:rPr sz="1800" b="0" i="1">
-                <a:solidFill>
-                  <a:srgbClr val="ECEFF1"/>
-                </a:solidFill>
-              </a:rPr>
-              <a:t>Module Intelligence Artificielle — 2ème année PEP · ENS</a:t>
-            </a:r>
-          </a:p>
-        </p:txBody>
-      </p:sp>
-      <p:sp>
-        <p:nvSpPr>
-          <p:cNvPr id="5" name="TextBox 4"/>
-          <p:cNvSpPr txBox="1"/>
-          <p:nvPr/>
-        </p:nvSpPr>
-        <p:spPr>
-          <a:xfrm>
-            <a:off x="822960" y="4663440"/>
-            <a:ext cx="10515600" cy="548640"/>
-          </a:xfrm>
-          <a:prstGeom prst="rect">
-            <a:avLst/>
-          </a:prstGeom>
-          <a:noFill/>
-        </p:spPr>
-        <p:txBody>
-          <a:bodyPr wrap="square">
-            <a:spAutoFit/>
-          </a:bodyPr>
-          <a:lstStyle/>
-          <a:p>
-            <a:r>
-              <a:rPr sz="1800" b="0" i="1">
-                <a:solidFill>
-                  <a:srgbClr val="ECEFF1"/>
-                </a:solidFill>
-              </a:rPr>
-              <a:t>Dr. Madani BELACEL — Université de Mostaganem</a:t>
-            </a:r>
-          </a:p>
-        </p:txBody>
-      </p:sp>
-      <p:sp>
-        <p:nvSpPr>
-          <p:cNvPr id="6" name="TextBox 5"/>
-          <p:cNvSpPr txBox="1"/>
-          <p:nvPr/>
-        </p:nvSpPr>
-        <p:spPr>
-          <a:xfrm>
-            <a:off x="822960" y="5852160"/>
-            <a:ext cx="10515600" cy="548640"/>
-          </a:xfrm>
-          <a:prstGeom prst="rect">
-            <a:avLst/>
-          </a:prstGeom>
-          <a:noFill/>
-        </p:spPr>
-        <p:txBody>
-          <a:bodyPr wrap="square">
-            <a:spAutoFit/>
-          </a:bodyPr>
-          <a:lstStyle/>
-          <a:p>
-            <a:r>
-              <a:rPr sz="1300" b="0" i="0">
-                <a:solidFill>
-                  <a:srgbClr val="78899C"/>
-                </a:solidFill>
-              </a:rPr>
-              <a:t>Module Intelligence Artificielle — PEP 2A · Dr. Madani BELACEL</a:t>
+              <a:t>Module « Intelligence Artificielle » — 2ème année PEP · ENS
+Dr. Madani BELACEL — Université de Mostaganem</a:t>
             </a:r>
           </a:p>
         </p:txBody>
@@ -3292,111 +3207,113 @@
       <p:grpSpPr/>
       <p:sp>
         <p:nvSpPr>
-          <p:cNvPr id="2" name="TextBox 1"/>
-          <p:cNvSpPr txBox="1"/>
-          <p:nvPr/>
-        </p:nvSpPr>
-        <p:spPr>
-          <a:xfrm>
-            <a:off x="822960" y="502920"/>
-            <a:ext cx="10789920" cy="914400"/>
-          </a:xfrm>
-          <a:prstGeom prst="rect">
-            <a:avLst/>
-          </a:prstGeom>
-          <a:noFill/>
-        </p:spPr>
-        <p:txBody>
-          <a:bodyPr wrap="square">
-            <a:spAutoFit/>
-          </a:bodyPr>
-          <a:lstStyle/>
-          <a:p>
-            <a:r>
-              <a:rPr sz="3000" b="1" i="0">
-                <a:solidFill>
-                  <a:srgbClr val="177BBE"/>
-                </a:solidFill>
-              </a:rPr>
-              <a:t>(sans titre)</a:t>
-            </a:r>
-          </a:p>
-        </p:txBody>
-      </p:sp>
-      <p:sp>
-        <p:nvSpPr>
-          <p:cNvPr id="3" name="TextBox 2"/>
-          <p:cNvSpPr txBox="1"/>
-          <p:nvPr/>
-        </p:nvSpPr>
-        <p:spPr>
-          <a:xfrm>
-            <a:off x="822960" y="1463040"/>
-            <a:ext cx="10515600" cy="4937760"/>
-          </a:xfrm>
-          <a:prstGeom prst="rect">
-            <a:avLst/>
-          </a:prstGeom>
-          <a:noFill/>
-        </p:spPr>
-        <p:txBody>
-          <a:bodyPr wrap="square">
-            <a:spAutoFit/>
-          </a:bodyPr>
-          <a:lstStyle/>
-          <a:p>
-            <a:pPr/>
-            <a:r>
-              <a:rPr sz="2000" b="0" i="0">
-                <a:solidFill>
-                  <a:srgbClr val="263238"/>
-                </a:solidFill>
-              </a:rPr>
-              <a:t>• ✏️ Activités et exercices</a:t>
-            </a:r>
-          </a:p>
-          <a:p>
-            <a:pPr/>
-            <a:r>
-              <a:rPr sz="2000" b="0" i="0">
-                <a:solidFill>
-                  <a:srgbClr val="263238"/>
-                </a:solidFill>
-              </a:rPr>
-              <a:t>• Tour de table et nuage de mots : chaque étudiant dit un mot associé à « IA », le formateur le note au tableau.</a:t>
-            </a:r>
-          </a:p>
-          <a:p>
-            <a:pPr/>
-            <a:r>
-              <a:rPr sz="2000" b="0" i="0">
-                <a:solidFill>
-                  <a:srgbClr val="263238"/>
-                </a:solidFill>
-              </a:rPr>
-              <a:t>• Activité « Intelligent ou programmé ? » : classer 8 situations (calculatrice, GPS, ChatGPT, aspirateur robot, réveil, sous-titres auto, jeu d'échecs, thermostat) dans un tableau à deux colonnes, puis discuter.</a:t>
-            </a:r>
-          </a:p>
-          <a:p>
-            <a:pPr/>
-            <a:r>
-              <a:rPr sz="2000" b="0" i="0">
-                <a:solidFill>
-                  <a:srgbClr val="263238"/>
-                </a:solidFill>
-              </a:rPr>
-              <a:t>• Démo guidée (si connexion disponible) : montrer une réponse de ChatGPT qui corrige une phrase de CP, et demander aux étudiants de repérer la qualité du texte.</a:t>
-            </a:r>
-          </a:p>
-          <a:p>
-            <a:pPr/>
-            <a:r>
-              <a:rPr sz="2000" b="0" i="0">
-                <a:solidFill>
-                  <a:srgbClr val="263238"/>
-                </a:solidFill>
-              </a:rPr>
-              <a:t>• Débat « IA et école primaire » : quelles peurs, quels espoirs ? Noter les arguments au tableau et les conserver pour la séance 10.</a:t>
+          <p:cNvPr id="2" name="Title 1"/>
+          <p:cNvSpPr>
+            <a:spLocks noGrp="1"/>
+          </p:cNvSpPr>
+          <p:nvPr>
+            <p:ph type="title"/>
+          </p:nvPr>
+        </p:nvSpPr>
+        <p:spPr/>
+        <p:txBody>
+          <a:bodyPr/>
+          <a:lstStyle/>
+          <a:p>
+            <a:r>
+              <a:t>📺 À regarder pour comprendre</a:t>
+            </a:r>
+            <a:r>
+              <a:t>  ·  Recommended videos</a:t>
+            </a:r>
+          </a:p>
+        </p:txBody>
+      </p:sp>
+      <p:sp>
+        <p:nvSpPr>
+          <p:cNvPr id="3" name="Content Placeholder 2"/>
+          <p:cNvSpPr>
+            <a:spLocks noGrp="1"/>
+          </p:cNvSpPr>
+          <p:nvPr>
+            <p:ph idx="1"/>
+          </p:nvPr>
+        </p:nvSpPr>
+        <p:spPr/>
+        <p:txBody>
+          <a:bodyPr wrap="square"/>
+          <a:lstStyle/>
+          <a:p>
+            <a:pPr>
+              <a:defRPr sz="2000"/>
+            </a:pPr>
+            <a:r>
+              <a:t>▶️ ما هو الذكاء الاصطناعي؟ شرح مبسط للمبتدئين (AI بالعربي) (ar)</a:t>
+            </a:r>
+          </a:p>
+          <a:p>
+            <a:pPr>
+              <a:defRPr sz="2000"/>
+            </a:pPr>
+            <a:r>
+              <a:t>▶️ ما هو الذكاء الاصطناعي؟ شرح مبسط (ar)</a:t>
+            </a:r>
+          </a:p>
+          <a:p>
+            <a:pPr>
+              <a:defRPr sz="2000"/>
+            </a:pPr>
+            <a:r>
+              <a:t>▶️ The Age of A.I. (Kurzgesagt) (en)</a:t>
+            </a:r>
+          </a:p>
+          <a:p/>
+          <a:p>
+            <a:pPr>
+              <a:defRPr sz="1300" i="1">
+                <a:solidFill>
+                  <a:srgbClr val="78899C"/>
+                </a:solidFill>
+              </a:defRPr>
+            </a:pPr>
+            <a:r>
+              <a:t>English summary:</a:t>
+            </a:r>
+          </a:p>
+          <a:p>
+            <a:pPr lvl="1">
+              <a:defRPr sz="1300">
+                <a:solidFill>
+                  <a:srgbClr val="546E7A"/>
+                </a:solidFill>
+              </a:defRPr>
+            </a:pPr>
+            <a:r>
+              <a:t>• https://www.youtube.com/watch?v=wdbb-X5qH4w</a:t>
+            </a:r>
+          </a:p>
+          <a:p>
+            <a:pPr lvl="1">
+              <a:defRPr sz="1300">
+                <a:solidFill>
+                  <a:srgbClr val="546E7A"/>
+                </a:solidFill>
+              </a:defRPr>
+            </a:pPr>
+            <a:r>
+              <a:t>• https://www.youtube.com/watch?v=vCKHeYQp8nk</a:t>
+            </a:r>
+          </a:p>
+          <a:p>
+            <a:pPr lvl="1">
+              <a:defRPr sz="1300">
+                <a:solidFill>
+                  <a:srgbClr val="546E7A"/>
+                </a:solidFill>
+              </a:defRPr>
+            </a:pPr>
+            <a:r>
+              <a:t>• https://www.youtube.com/watch?v=UwsrzCVZAb8</a:t>
             </a:r>
           </a:p>
         </p:txBody>
@@ -3421,122 +3338,109 @@
       <p:grpSpPr/>
       <p:sp>
         <p:nvSpPr>
-          <p:cNvPr id="2" name="TextBox 1"/>
-          <p:cNvSpPr txBox="1"/>
-          <p:nvPr/>
-        </p:nvSpPr>
-        <p:spPr>
-          <a:xfrm>
-            <a:off x="822960" y="502920"/>
-            <a:ext cx="10789920" cy="914400"/>
-          </a:xfrm>
-          <a:prstGeom prst="rect">
-            <a:avLst/>
-          </a:prstGeom>
-          <a:noFill/>
-        </p:spPr>
-        <p:txBody>
-          <a:bodyPr wrap="square">
-            <a:spAutoFit/>
-          </a:bodyPr>
-          <a:lstStyle/>
-          <a:p>
-            <a:r>
-              <a:rPr sz="3000" b="1" i="0">
-                <a:solidFill>
-                  <a:srgbClr val="177BBE"/>
-                </a:solidFill>
-              </a:rPr>
-              <a:t>(sans titre)</a:t>
-            </a:r>
-          </a:p>
-        </p:txBody>
-      </p:sp>
-      <p:sp>
-        <p:nvSpPr>
-          <p:cNvPr id="3" name="TextBox 2"/>
-          <p:cNvSpPr txBox="1"/>
-          <p:nvPr/>
-        </p:nvSpPr>
-        <p:spPr>
-          <a:xfrm>
-            <a:off x="822960" y="1463040"/>
-            <a:ext cx="10515600" cy="4937760"/>
-          </a:xfrm>
-          <a:prstGeom prst="rect">
-            <a:avLst/>
-          </a:prstGeom>
-          <a:noFill/>
-        </p:spPr>
-        <p:txBody>
-          <a:bodyPr wrap="square">
-            <a:spAutoFit/>
-          </a:bodyPr>
-          <a:lstStyle/>
-          <a:p>
-            <a:pPr/>
-            <a:r>
-              <a:rPr sz="2000" b="0" i="0">
-                <a:solidFill>
-                  <a:srgbClr val="263238"/>
-                </a:solidFill>
-              </a:rPr>
-              <a:t>• 🧠 À retenir</a:t>
-            </a:r>
-          </a:p>
-          <a:p>
-            <a:pPr/>
-            <a:r>
-              <a:rPr sz="2000" b="0" i="0">
-                <a:solidFill>
-                  <a:srgbClr val="263238"/>
-                </a:solidFill>
-              </a:rPr>
-              <a:t>• L'IA est un programme qui apprend à partir de données (exemples) pour reconnaître, comprendre ou décider.</a:t>
-            </a:r>
-          </a:p>
-          <a:p>
-            <a:pPr/>
-            <a:r>
-              <a:rPr sz="2000" b="0" i="0">
-                <a:solidFill>
-                  <a:srgbClr val="263238"/>
-                </a:solidFill>
-              </a:rPr>
-              <a:t>• Aujourd'hui, nous n'utilisons que de l'IA faible (étroite), spécialisée dans une seule tâche.</a:t>
-            </a:r>
-          </a:p>
-          <a:p>
-            <a:pPr/>
-            <a:r>
-              <a:rPr sz="2000" b="0" i="0">
-                <a:solidFill>
-                  <a:srgbClr val="263238"/>
-                </a:solidFill>
-              </a:rPr>
-              <a:t>• L'IA ne « pense » pas comme un humain : elle calcule et imite, et elle peut se tromper (hallucinations).</a:t>
-            </a:r>
-          </a:p>
-          <a:p>
-            <a:pPr/>
-            <a:r>
-              <a:rPr sz="2000" b="0" i="0">
-                <a:solidFill>
-                  <a:srgbClr val="263238"/>
-                </a:solidFill>
-              </a:rPr>
-              <a:t>• Pour l'enseignant : l'IA est un assistant de préparation, jamais un remplaçant du jugement professionnel.</a:t>
-            </a:r>
-          </a:p>
-          <a:p>
-            <a:pPr/>
-            <a:r>
-              <a:rPr sz="2000" b="0" i="0">
-                <a:solidFill>
-                  <a:srgbClr val="263238"/>
-                </a:solidFill>
-              </a:rPr>
-              <a:t>• Dates clés : 1956 (création du terme), 1997 (Deep Blue), 2012 (deep learning), 2022 (ChatGPT).</a:t>
+          <p:cNvPr id="2" name="Title 1"/>
+          <p:cNvSpPr>
+            <a:spLocks noGrp="1"/>
+          </p:cNvSpPr>
+          <p:nvPr>
+            <p:ph type="title"/>
+          </p:nvPr>
+        </p:nvSpPr>
+        <p:spPr/>
+        <p:txBody>
+          <a:bodyPr/>
+          <a:lstStyle/>
+          <a:p>
+            <a:r>
+              <a:t>✏️ Exercice guidé (15 min)</a:t>
+            </a:r>
+            <a:r>
+              <a:t>  ·  Guided exercise</a:t>
+            </a:r>
+          </a:p>
+        </p:txBody>
+      </p:sp>
+      <p:sp>
+        <p:nvSpPr>
+          <p:cNvPr id="3" name="Content Placeholder 2"/>
+          <p:cNvSpPr>
+            <a:spLocks noGrp="1"/>
+          </p:cNvSpPr>
+          <p:nvPr>
+            <p:ph idx="1"/>
+          </p:nvPr>
+        </p:nvSpPr>
+        <p:spPr/>
+        <p:txBody>
+          <a:bodyPr wrap="square"/>
+          <a:lstStyle/>
+          <a:p>
+            <a:pPr>
+              <a:defRPr sz="2000"/>
+            </a:pPr>
+            <a:r>
+              <a:t>Classe les 6 affirmations suivantes en Vrai (V) ou Faux (F), puis justifie en une ligne : 1) L'IA pense comme un humain. 2) L'IA a été entraînée sur des textes. 3) L'IA donne toujours des bonnes réponses. 4) L'IA peut inventer une référence. 5) L'IA remplace le professeur. 6) L'IA peut t'aider à réviser si tu vérifies.</a:t>
+            </a:r>
+          </a:p>
+          <a:p>
+            <a:pPr>
+              <a:defRPr sz="2000"/>
+            </a:pPr>
+            <a:r>
+              <a:t>—</a:t>
+            </a:r>
+          </a:p>
+          <a:p>
+            <a:pPr>
+              <a:defRPr sz="2000"/>
+            </a:pPr>
+            <a:r>
+              <a:t>▶ Solution :</a:t>
+            </a:r>
+          </a:p>
+          <a:p>
+            <a:pPr>
+              <a:defRPr sz="2000"/>
+            </a:pPr>
+            <a:r>
+              <a:t>1) F — l'IA calcule des probabilités, elle n'a ni conscience ni pensées. 2) V — c'est son apprentissage. 3) F — elle peut se tromper et même inventer (halluciner). 4) V — c'est très fréquent, d'où la règle « vérifie ». 5) F — elle assiste l'étudiant, l'évaluation et le dialogue restent humains. 6) V — à condition de vérifier le contenu avec ton cours et tes sources.</a:t>
+            </a:r>
+          </a:p>
+          <a:p/>
+          <a:p>
+            <a:pPr>
+              <a:defRPr sz="1300" i="1">
+                <a:solidFill>
+                  <a:srgbClr val="78899C"/>
+                </a:solidFill>
+              </a:defRPr>
+            </a:pPr>
+            <a:r>
+              <a:t>English summary:</a:t>
+            </a:r>
+          </a:p>
+          <a:p>
+            <a:pPr lvl="1">
+              <a:defRPr sz="1300">
+                <a:solidFill>
+                  <a:srgbClr val="546E7A"/>
+                </a:solidFill>
+              </a:defRPr>
+            </a:pPr>
+            <a:r>
+              <a:t>• Classify the 6 statements as True (T) or False (F), then justify in one line: 1) AI thinks like a human. 2) AI was trained on texts. 3) AI always gives good answers. 4) AI can invent a reference. 5) AI replaces the teacher. 6) AI can help you revise if you check.</a:t>
+            </a:r>
+          </a:p>
+          <a:p>
+            <a:pPr lvl="1">
+              <a:defRPr sz="1300">
+                <a:solidFill>
+                  <a:srgbClr val="546E7A"/>
+                </a:solidFill>
+              </a:defRPr>
+            </a:pPr>
+            <a:r>
+              <a:t>• 1) F — AI computes probabilities; it has neither consciousness nor thoughts. 2) T — that is its training. 3) F — it can err and even invent (hallucinate). 4) T — very common, hence the "verify" rule. 5) F — it assists the student; assessment and dialogue remain human. 6) T — provided you check the content against your lesson and sources.</a:t>
             </a:r>
           </a:p>
         </p:txBody>
@@ -3550,6 +3454,467 @@
 </file>
 
 <file path=ppt/slides/slide12.xml><?xml version="1.0" encoding="utf-8"?>
+<p:sld xmlns:a="http://schemas.openxmlformats.org/drawingml/2006/main" xmlns:p="http://schemas.openxmlformats.org/presentationml/2006/main" xmlns:r="http://schemas.openxmlformats.org/officeDocument/2006/relationships">
+  <p:cSld>
+    <p:spTree>
+      <p:nvGrpSpPr>
+        <p:cNvPr id="1" name=""/>
+        <p:cNvGrpSpPr/>
+        <p:nvPr/>
+      </p:nvGrpSpPr>
+      <p:grpSpPr/>
+      <p:sp>
+        <p:nvSpPr>
+          <p:cNvPr id="2" name="Title 1"/>
+          <p:cNvSpPr>
+            <a:spLocks noGrp="1"/>
+          </p:cNvSpPr>
+          <p:nvPr>
+            <p:ph type="title"/>
+          </p:nvPr>
+        </p:nvSpPr>
+        <p:spPr/>
+        <p:txBody>
+          <a:bodyPr/>
+          <a:lstStyle/>
+          <a:p>
+            <a:r>
+              <a:t>🧠 Fiche de synthèse — points clés</a:t>
+            </a:r>
+            <a:r>
+              <a:t>  ·  Summary sheet</a:t>
+            </a:r>
+          </a:p>
+        </p:txBody>
+      </p:sp>
+      <p:sp>
+        <p:nvSpPr>
+          <p:cNvPr id="3" name="Content Placeholder 2"/>
+          <p:cNvSpPr>
+            <a:spLocks noGrp="1"/>
+          </p:cNvSpPr>
+          <p:nvPr>
+            <p:ph idx="1"/>
+          </p:nvPr>
+        </p:nvSpPr>
+        <p:spPr/>
+        <p:txBody>
+          <a:bodyPr wrap="square"/>
+          <a:lstStyle/>
+          <a:p>
+            <a:pPr>
+              <a:defRPr sz="2000"/>
+            </a:pPr>
+            <a:r>
+              <a:t>L'IA est un programme qui apprend à partir d'exemples pour imiter des capacités humaines.</a:t>
+            </a:r>
+          </a:p>
+          <a:p>
+            <a:pPr>
+              <a:defRPr sz="2000"/>
+            </a:pPr>
+            <a:r>
+              <a:t>Un chatbot est une machine à prédire le mot suivant, entraînée à être convaincante — pas vraie.</a:t>
+            </a:r>
+          </a:p>
+          <a:p>
+            <a:pPr>
+              <a:defRPr sz="2000"/>
+            </a:pPr>
+            <a:r>
+              <a:t>Hallucination = invention confiante. C'est fréquent, pas un bug.</a:t>
+            </a:r>
+          </a:p>
+          <a:p>
+            <a:pPr>
+              <a:defRPr sz="2000"/>
+            </a:pPr>
+            <a:r>
+              <a:t>3 familles : IA faible (tout ce qu'on utilise), générale (future), super-IA (films).</a:t>
+            </a:r>
+          </a:p>
+          <a:p>
+            <a:pPr>
+              <a:defRPr sz="2000"/>
+            </a:pPr>
+            <a:r>
+              <a:t>3 règles d'or : vérifier, citer, garder ton jugement.</a:t>
+            </a:r>
+          </a:p>
+          <a:p/>
+          <a:p>
+            <a:pPr>
+              <a:defRPr sz="1300" i="1">
+                <a:solidFill>
+                  <a:srgbClr val="78899C"/>
+                </a:solidFill>
+              </a:defRPr>
+            </a:pPr>
+            <a:r>
+              <a:t>English summary:</a:t>
+            </a:r>
+          </a:p>
+          <a:p>
+            <a:pPr lvl="1">
+              <a:defRPr sz="1300">
+                <a:solidFill>
+                  <a:srgbClr val="546E7A"/>
+                </a:solidFill>
+              </a:defRPr>
+            </a:pPr>
+            <a:r>
+              <a:t>• AI is a program that learns from examples to imitate human abilities.</a:t>
+            </a:r>
+          </a:p>
+          <a:p>
+            <a:pPr lvl="1">
+              <a:defRPr sz="1300">
+                <a:solidFill>
+                  <a:srgbClr val="546E7A"/>
+                </a:solidFill>
+              </a:defRPr>
+            </a:pPr>
+            <a:r>
+              <a:t>• A chatbot is a next-word prediction machine, trained to be convincing — not true.</a:t>
+            </a:r>
+          </a:p>
+          <a:p>
+            <a:pPr lvl="1">
+              <a:defRPr sz="1300">
+                <a:solidFill>
+                  <a:srgbClr val="546E7A"/>
+                </a:solidFill>
+              </a:defRPr>
+            </a:pPr>
+            <a:r>
+              <a:t>• Hallucination = confident invention. It is common, not a bug.</a:t>
+            </a:r>
+          </a:p>
+        </p:txBody>
+      </p:sp>
+    </p:spTree>
+  </p:cSld>
+  <p:clrMapOvr>
+    <a:masterClrMapping/>
+  </p:clrMapOvr>
+</p:sld>
+</file>
+
+<file path=ppt/slides/slide13.xml><?xml version="1.0" encoding="utf-8"?>
+<p:sld xmlns:a="http://schemas.openxmlformats.org/drawingml/2006/main" xmlns:p="http://schemas.openxmlformats.org/presentationml/2006/main" xmlns:r="http://schemas.openxmlformats.org/officeDocument/2006/relationships">
+  <p:cSld>
+    <p:spTree>
+      <p:nvGrpSpPr>
+        <p:cNvPr id="1" name=""/>
+        <p:cNvGrpSpPr/>
+        <p:nvPr/>
+      </p:nvGrpSpPr>
+      <p:grpSpPr/>
+      <p:sp>
+        <p:nvSpPr>
+          <p:cNvPr id="2" name="Title 1"/>
+          <p:cNvSpPr>
+            <a:spLocks noGrp="1"/>
+          </p:cNvSpPr>
+          <p:nvPr>
+            <p:ph type="title"/>
+          </p:nvPr>
+        </p:nvSpPr>
+        <p:spPr/>
+        <p:txBody>
+          <a:bodyPr/>
+          <a:lstStyle/>
+          <a:p>
+            <a:r>
+              <a:t>🧠 Quiz éclair (3 questions)</a:t>
+            </a:r>
+            <a:r>
+              <a:t>  ·  Quick quiz</a:t>
+            </a:r>
+          </a:p>
+        </p:txBody>
+      </p:sp>
+      <p:sp>
+        <p:nvSpPr>
+          <p:cNvPr id="3" name="Content Placeholder 2"/>
+          <p:cNvSpPr>
+            <a:spLocks noGrp="1"/>
+          </p:cNvSpPr>
+          <p:nvPr>
+            <p:ph idx="1"/>
+          </p:nvPr>
+        </p:nvSpPr>
+        <p:spPr/>
+        <p:txBody>
+          <a:bodyPr wrap="square"/>
+          <a:lstStyle/>
+          <a:p>
+            <a:pPr>
+              <a:defRPr sz="2000"/>
+            </a:pPr>
+            <a:r>
+              <a:t>Q1. Comment un chatbot produit-il sa réponse ?</a:t>
+            </a:r>
+            <a:br/>
+            <a:r>
+              <a:t>   ✅ Il prédit le mot le plus probable, mot après mot</a:t>
+            </a:r>
+          </a:p>
+          <a:p>
+            <a:pPr>
+              <a:defRPr sz="2000"/>
+            </a:pPr>
+            <a:r>
+              <a:t>Q2. Qu'est-ce qu'une « hallucination » d'IA ?</a:t>
+            </a:r>
+            <a:br/>
+            <a:r>
+              <a:t>   ✅ Une information inventée dite avec assurance</a:t>
+            </a:r>
+          </a:p>
+          <a:p>
+            <a:pPr>
+              <a:defRPr sz="2000"/>
+            </a:pPr>
+            <a:r>
+              <a:t>Q3. ChatGPT, aujourd'hui, c'est…</a:t>
+            </a:r>
+            <a:br/>
+            <a:r>
+              <a:t>   ✅ Une IA faible (étroite)</a:t>
+            </a:r>
+          </a:p>
+          <a:p/>
+          <a:p>
+            <a:pPr>
+              <a:defRPr sz="1300" i="1">
+                <a:solidFill>
+                  <a:srgbClr val="78899C"/>
+                </a:solidFill>
+              </a:defRPr>
+            </a:pPr>
+            <a:r>
+              <a:t>English summary:</a:t>
+            </a:r>
+          </a:p>
+          <a:p>
+            <a:pPr lvl="1">
+              <a:defRPr sz="1300">
+                <a:solidFill>
+                  <a:srgbClr val="546E7A"/>
+                </a:solidFill>
+              </a:defRPr>
+            </a:pPr>
+            <a:r>
+              <a:t>• How does a chatbot produce its answer?</a:t>
+            </a:r>
+          </a:p>
+          <a:p>
+            <a:pPr lvl="1">
+              <a:defRPr sz="1300">
+                <a:solidFill>
+                  <a:srgbClr val="546E7A"/>
+                </a:solidFill>
+              </a:defRPr>
+            </a:pPr>
+            <a:r>
+              <a:t>• What is an AI "hallucination"?</a:t>
+            </a:r>
+          </a:p>
+          <a:p>
+            <a:pPr lvl="1">
+              <a:defRPr sz="1300">
+                <a:solidFill>
+                  <a:srgbClr val="546E7A"/>
+                </a:solidFill>
+              </a:defRPr>
+            </a:pPr>
+            <a:r>
+              <a:t>• ChatGPT, today, is…</a:t>
+            </a:r>
+          </a:p>
+        </p:txBody>
+      </p:sp>
+    </p:spTree>
+  </p:cSld>
+  <p:clrMapOvr>
+    <a:masterClrMapping/>
+  </p:clrMapOvr>
+</p:sld>
+</file>
+
+<file path=ppt/slides/slide14.xml><?xml version="1.0" encoding="utf-8"?>
+<p:sld xmlns:a="http://schemas.openxmlformats.org/drawingml/2006/main" xmlns:p="http://schemas.openxmlformats.org/presentationml/2006/main" xmlns:r="http://schemas.openxmlformats.org/officeDocument/2006/relationships">
+  <p:cSld>
+    <p:spTree>
+      <p:nvGrpSpPr>
+        <p:cNvPr id="1" name=""/>
+        <p:cNvGrpSpPr/>
+        <p:nvPr/>
+      </p:nvGrpSpPr>
+      <p:grpSpPr/>
+      <p:sp>
+        <p:nvSpPr>
+          <p:cNvPr id="2" name="Title 1"/>
+          <p:cNvSpPr>
+            <a:spLocks noGrp="1"/>
+          </p:cNvSpPr>
+          <p:nvPr>
+            <p:ph type="title"/>
+          </p:nvPr>
+        </p:nvSpPr>
+        <p:spPr/>
+        <p:txBody>
+          <a:bodyPr/>
+          <a:lstStyle/>
+          <a:p>
+            <a:r>
+              <a:t>À retenir</a:t>
+            </a:r>
+            <a:r>
+              <a:t>  ·  Key takeaways</a:t>
+            </a:r>
+          </a:p>
+        </p:txBody>
+      </p:sp>
+      <p:sp>
+        <p:nvSpPr>
+          <p:cNvPr id="3" name="Content Placeholder 2"/>
+          <p:cNvSpPr>
+            <a:spLocks noGrp="1"/>
+          </p:cNvSpPr>
+          <p:nvPr>
+            <p:ph idx="1"/>
+          </p:nvPr>
+        </p:nvSpPr>
+        <p:spPr/>
+        <p:txBody>
+          <a:bodyPr wrap="square"/>
+          <a:lstStyle/>
+          <a:p>
+            <a:pPr>
+              <a:defRPr sz="2000"/>
+            </a:pPr>
+            <a:r>
+              <a:t>L'IA = programme qui apprend à partir d'exemples pour imiter des capacités humaines.</a:t>
+            </a:r>
+          </a:p>
+          <a:p>
+            <a:pPr>
+              <a:defRPr sz="2000"/>
+            </a:pPr>
+            <a:r>
+              <a:t>Un chatbot prédit le mot suivant ; il peut être convaincant sans être vrai. Hallucinations : fréquentes.</a:t>
+            </a:r>
+          </a:p>
+          <a:p>
+            <a:pPr>
+              <a:defRPr sz="2000"/>
+            </a:pPr>
+            <a:r>
+              <a:t>5 usages pour tes études : rechercher, résumer, rédiger, réviser, organiser.</a:t>
+            </a:r>
+          </a:p>
+          <a:p>
+            <a:pPr>
+              <a:defRPr sz="2000"/>
+            </a:pPr>
+            <a:r>
+              <a:t>L'IA ne pense pas, ne ressent pas, n'apprend rien à ta place : la compréhension reste ton travail.</a:t>
+            </a:r>
+          </a:p>
+          <a:p>
+            <a:pPr>
+              <a:defRPr sz="2000"/>
+            </a:pPr>
+            <a:r>
+              <a:t>3 règles d'or : vérifier, citer, garder ton jugement.</a:t>
+            </a:r>
+          </a:p>
+          <a:p/>
+          <a:p>
+            <a:pPr>
+              <a:defRPr sz="1300" i="1">
+                <a:solidFill>
+                  <a:srgbClr val="78899C"/>
+                </a:solidFill>
+              </a:defRPr>
+            </a:pPr>
+            <a:r>
+              <a:t>English summary:</a:t>
+            </a:r>
+          </a:p>
+          <a:p>
+            <a:pPr lvl="1">
+              <a:defRPr sz="1300">
+                <a:solidFill>
+                  <a:srgbClr val="546E7A"/>
+                </a:solidFill>
+              </a:defRPr>
+            </a:pPr>
+            <a:r>
+              <a:t>• AI = a program that learns from examples to imitate human abilities.</a:t>
+            </a:r>
+          </a:p>
+          <a:p>
+            <a:pPr lvl="1">
+              <a:defRPr sz="1300">
+                <a:solidFill>
+                  <a:srgbClr val="546E7A"/>
+                </a:solidFill>
+              </a:defRPr>
+            </a:pPr>
+            <a:r>
+              <a:t>• A chatbot predicts the next word; it can be convincing without being true. Hallucinations: common.</a:t>
+            </a:r>
+          </a:p>
+          <a:p>
+            <a:pPr lvl="1">
+              <a:defRPr sz="1300">
+                <a:solidFill>
+                  <a:srgbClr val="546E7A"/>
+                </a:solidFill>
+              </a:defRPr>
+            </a:pPr>
+            <a:r>
+              <a:t>• 5 uses for your studies: search, summarise, write, revise, organise.</a:t>
+            </a:r>
+          </a:p>
+          <a:p>
+            <a:pPr lvl="1">
+              <a:defRPr sz="1300">
+                <a:solidFill>
+                  <a:srgbClr val="546E7A"/>
+                </a:solidFill>
+              </a:defRPr>
+            </a:pPr>
+            <a:r>
+              <a:t>• AI does not think, does not feel, learns nothing for you: understanding remains your work.</a:t>
+            </a:r>
+          </a:p>
+          <a:p>
+            <a:pPr lvl="1">
+              <a:defRPr sz="1300">
+                <a:solidFill>
+                  <a:srgbClr val="546E7A"/>
+                </a:solidFill>
+              </a:defRPr>
+            </a:pPr>
+            <a:r>
+              <a:t>• 3 golden rules: verify, cite, keep your judgement.</a:t>
+            </a:r>
+          </a:p>
+        </p:txBody>
+      </p:sp>
+    </p:spTree>
+  </p:cSld>
+  <p:clrMapOvr>
+    <a:masterClrMapping/>
+  </p:clrMapOvr>
+</p:sld>
+</file>
+
+<file path=ppt/slides/slide15.xml><?xml version="1.0" encoding="utf-8"?>
 <p:sld xmlns:a="http://schemas.openxmlformats.org/drawingml/2006/main" xmlns:p="http://schemas.openxmlformats.org/presentationml/2006/main" xmlns:r="http://schemas.openxmlformats.org/officeDocument/2006/relationships">
   <p:cSld>
     <p:bg>
@@ -3575,7 +3940,50 @@
         </p:nvSpPr>
         <p:spPr>
           <a:xfrm>
-            <a:off x="822960" y="1920240"/>
+            <a:off x="822960" y="1828800"/>
+            <a:ext cx="10515600" cy="1828800"/>
+          </a:xfrm>
+          <a:prstGeom prst="rect">
+            <a:avLst/>
+          </a:prstGeom>
+          <a:noFill/>
+        </p:spPr>
+        <p:txBody>
+          <a:bodyPr wrap="square">
+            <a:spAutoFit/>
+          </a:bodyPr>
+          <a:lstStyle/>
+          <a:p>
+            <a:r>
+              <a:rPr sz="4000" b="1">
+                <a:solidFill>
+                  <a:srgbClr val="FFFFFF"/>
+                </a:solidFill>
+              </a:rPr>
+              <a:t>Séance 01 — Qu'est-ce que l'IA ? Introduction et démystification</a:t>
+            </a:r>
+          </a:p>
+          <a:p>
+            <a:r>
+              <a:rPr sz="2000">
+                <a:solidFill>
+                  <a:srgbClr val="ECEFF1"/>
+                </a:solidFill>
+              </a:rPr>
+              <a:t>What is AI? Introduction and demystification</a:t>
+            </a:r>
+          </a:p>
+        </p:txBody>
+      </p:sp>
+      <p:sp>
+        <p:nvSpPr>
+          <p:cNvPr id="3" name="TextBox 2"/>
+          <p:cNvSpPr txBox="1"/>
+          <p:nvPr/>
+        </p:nvSpPr>
+        <p:spPr>
+          <a:xfrm>
+            <a:off x="822960" y="4023360"/>
             <a:ext cx="10515600" cy="1463040"/>
           </a:xfrm>
           <a:prstGeom prst="rect">
@@ -3590,144 +3998,14 @@
           <a:lstStyle/>
           <a:p>
             <a:r>
-              <a:rPr sz="4000" b="1" i="0">
-                <a:solidFill>
-                  <a:srgbClr val="FFFFFF"/>
+              <a:rPr sz="1500">
+                <a:solidFill>
+                  <a:srgbClr val="ECEFF1"/>
                 </a:solidFill>
               </a:rPr>
-              <a:t>🎓 Merci de votre attention</a:t>
-            </a:r>
-          </a:p>
-        </p:txBody>
-      </p:sp>
-      <p:sp>
-        <p:nvSpPr>
-          <p:cNvPr id="3" name="TextBox 2"/>
-          <p:cNvSpPr txBox="1"/>
-          <p:nvPr/>
-        </p:nvSpPr>
-        <p:spPr>
-          <a:xfrm>
-            <a:off x="822960" y="3566160"/>
-            <a:ext cx="10515600" cy="548640"/>
-          </a:xfrm>
-          <a:prstGeom prst="rect">
-            <a:avLst/>
-          </a:prstGeom>
-          <a:noFill/>
-        </p:spPr>
-        <p:txBody>
-          <a:bodyPr wrap="square">
-            <a:spAutoFit/>
-          </a:bodyPr>
-          <a:lstStyle/>
-          <a:p>
-            <a:r>
-              <a:rPr sz="1800" b="0" i="1">
-                <a:solidFill>
-                  <a:srgbClr val="ECEFF1"/>
-                </a:solidFill>
-              </a:rPr>
-              <a:t>Séance 01 — Introduction à l'Intelligence Artificielle</a:t>
-            </a:r>
-          </a:p>
-        </p:txBody>
-      </p:sp>
-      <p:sp>
-        <p:nvSpPr>
-          <p:cNvPr id="4" name="TextBox 3"/>
-          <p:cNvSpPr txBox="1"/>
-          <p:nvPr/>
-        </p:nvSpPr>
-        <p:spPr>
-          <a:xfrm>
-            <a:off x="822960" y="4114800"/>
-            <a:ext cx="10515600" cy="548640"/>
-          </a:xfrm>
-          <a:prstGeom prst="rect">
-            <a:avLst/>
-          </a:prstGeom>
-          <a:noFill/>
-        </p:spPr>
-        <p:txBody>
-          <a:bodyPr wrap="square">
-            <a:spAutoFit/>
-          </a:bodyPr>
-          <a:lstStyle/>
-          <a:p>
-            <a:r>
-              <a:rPr sz="1800" b="0" i="1">
-                <a:solidFill>
-                  <a:srgbClr val="ECEFF1"/>
-                </a:solidFill>
-              </a:rPr>
-              <a:t>Prochaine séance : venez avec un ordinateur ou un smartphone.</a:t>
-            </a:r>
-          </a:p>
-        </p:txBody>
-      </p:sp>
-      <p:sp>
-        <p:nvSpPr>
-          <p:cNvPr id="5" name="TextBox 4"/>
-          <p:cNvSpPr txBox="1"/>
-          <p:nvPr/>
-        </p:nvSpPr>
-        <p:spPr>
-          <a:xfrm>
-            <a:off x="822960" y="4663440"/>
-            <a:ext cx="10515600" cy="548640"/>
-          </a:xfrm>
-          <a:prstGeom prst="rect">
-            <a:avLst/>
-          </a:prstGeom>
-          <a:noFill/>
-        </p:spPr>
-        <p:txBody>
-          <a:bodyPr wrap="square">
-            <a:spAutoFit/>
-          </a:bodyPr>
-          <a:lstStyle/>
-          <a:p>
-            <a:r>
-              <a:rPr sz="1800" b="0" i="1">
-                <a:solidFill>
-                  <a:srgbClr val="ECEFF1"/>
-                </a:solidFill>
-              </a:rPr>
-              <a:t>Dr. Madani BELACEL — ENS Université de Mostaganem</a:t>
-            </a:r>
-          </a:p>
-        </p:txBody>
-      </p:sp>
-      <p:sp>
-        <p:nvSpPr>
-          <p:cNvPr id="6" name="TextBox 5"/>
-          <p:cNvSpPr txBox="1"/>
-          <p:nvPr/>
-        </p:nvSpPr>
-        <p:spPr>
-          <a:xfrm>
-            <a:off x="822960" y="5852160"/>
-            <a:ext cx="10515600" cy="548640"/>
-          </a:xfrm>
-          <a:prstGeom prst="rect">
-            <a:avLst/>
-          </a:prstGeom>
-          <a:noFill/>
-        </p:spPr>
-        <p:txBody>
-          <a:bodyPr wrap="square">
-            <a:spAutoFit/>
-          </a:bodyPr>
-          <a:lstStyle/>
-          <a:p>
-            <a:r>
-              <a:rPr sz="1300" b="0" i="0">
-                <a:solidFill>
-                  <a:srgbClr val="78899C"/>
-                </a:solidFill>
-              </a:rPr>
-              <a:t>Module Intelligence Artificielle — PEP 2A · Dr. Madani BELACEL</a:t>
+              <a:t>Module « Intelligence Artificielle » — 2ème année PEP · ENS
+Dr. Madani BELACEL — Université de Mostaganem
+Prochaine séance : à venir.</a:t>
             </a:r>
           </a:p>
         </p:txBody>
@@ -3752,133 +4030,153 @@
       <p:grpSpPr/>
       <p:sp>
         <p:nvSpPr>
-          <p:cNvPr id="2" name="TextBox 1"/>
-          <p:cNvSpPr txBox="1"/>
-          <p:nvPr/>
-        </p:nvSpPr>
-        <p:spPr>
-          <a:xfrm>
-            <a:off x="822960" y="502920"/>
-            <a:ext cx="10789920" cy="914400"/>
-          </a:xfrm>
-          <a:prstGeom prst="rect">
-            <a:avLst/>
-          </a:prstGeom>
-          <a:noFill/>
-        </p:spPr>
-        <p:txBody>
-          <a:bodyPr wrap="square">
-            <a:spAutoFit/>
-          </a:bodyPr>
-          <a:lstStyle/>
-          <a:p>
-            <a:r>
-              <a:rPr sz="3000" b="1" i="0">
-                <a:solidFill>
-                  <a:srgbClr val="177BBE"/>
-                </a:solidFill>
-              </a:rPr>
-              <a:t>(sans titre)</a:t>
-            </a:r>
-          </a:p>
-        </p:txBody>
-      </p:sp>
-      <p:sp>
-        <p:nvSpPr>
-          <p:cNvPr id="3" name="TextBox 2"/>
-          <p:cNvSpPr txBox="1"/>
-          <p:nvPr/>
-        </p:nvSpPr>
-        <p:spPr>
-          <a:xfrm>
-            <a:off x="822960" y="1463040"/>
-            <a:ext cx="10515600" cy="4937760"/>
-          </a:xfrm>
-          <a:prstGeom prst="rect">
-            <a:avLst/>
-          </a:prstGeom>
-          <a:noFill/>
-        </p:spPr>
-        <p:txBody>
-          <a:bodyPr wrap="square">
-            <a:spAutoFit/>
-          </a:bodyPr>
-          <a:lstStyle/>
-          <a:p>
-            <a:pPr/>
-            <a:r>
-              <a:rPr sz="2000" b="0" i="0">
-                <a:solidFill>
-                  <a:srgbClr val="263238"/>
-                </a:solidFill>
-              </a:rPr>
-              <a:t>• ⏱️ Déroulé de la séance (1 h 30)</a:t>
-            </a:r>
-          </a:p>
-          <a:p>
-            <a:pPr/>
-            <a:r>
-              <a:rPr sz="2000" b="0" i="0">
-                <a:solidFill>
-                  <a:srgbClr val="263238"/>
-                </a:solidFill>
-              </a:rPr>
-              <a:t>• 00–10 — Accueil et mise en route</a:t>
-            </a:r>
-          </a:p>
-          <a:p>
-            <a:pPr/>
-            <a:r>
-              <a:rPr sz="2000" b="0" i="0">
-                <a:solidFill>
-                  <a:srgbClr val="263238"/>
-                </a:solidFill>
-              </a:rPr>
-              <a:t>• 10–35 — Partie 1 : Définitions et petite histoire</a:t>
-            </a:r>
-          </a:p>
-          <a:p>
-            <a:pPr/>
-            <a:r>
-              <a:rPr sz="2000" b="0" i="0">
-                <a:solidFill>
-                  <a:srgbClr val="263238"/>
-                </a:solidFill>
-              </a:rPr>
-              <a:t>• 35–50 — Partie 2 : Les 3 familles d'IA</a:t>
-            </a:r>
-          </a:p>
-          <a:p>
-            <a:pPr/>
-            <a:r>
-              <a:rPr sz="2000" b="0" i="0">
-                <a:solidFill>
-                  <a:srgbClr val="263238"/>
-                </a:solidFill>
-              </a:rPr>
-              <a:t>• 50–70 — Partie 3 : Démystification et intérêt pour le primaire</a:t>
-            </a:r>
-          </a:p>
-          <a:p>
-            <a:pPr/>
-            <a:r>
-              <a:rPr sz="2000" b="0" i="0">
-                <a:solidFill>
-                  <a:srgbClr val="263238"/>
-                </a:solidFill>
-              </a:rPr>
-              <a:t>• 70–80 — Activité pratique : « Intelligent ou programmé ? »</a:t>
-            </a:r>
-          </a:p>
-          <a:p>
-            <a:pPr/>
-            <a:r>
-              <a:rPr sz="2000" b="0" i="0">
-                <a:solidFill>
-                  <a:srgbClr val="263238"/>
-                </a:solidFill>
-              </a:rPr>
-              <a:t>• 80–90 — Synthèse, « à retenir », questions et annonce de la séance 2</a:t>
+          <p:cNvPr id="2" name="Title 1"/>
+          <p:cNvSpPr>
+            <a:spLocks noGrp="1"/>
+          </p:cNvSpPr>
+          <p:nvPr>
+            <p:ph type="title"/>
+          </p:nvPr>
+        </p:nvSpPr>
+        <p:spPr/>
+        <p:txBody>
+          <a:bodyPr/>
+          <a:lstStyle/>
+          <a:p>
+            <a:r>
+              <a:t>Objectifs de la séance</a:t>
+            </a:r>
+            <a:r>
+              <a:t>  ·  Learning objectives</a:t>
+            </a:r>
+          </a:p>
+        </p:txBody>
+      </p:sp>
+      <p:sp>
+        <p:nvSpPr>
+          <p:cNvPr id="3" name="Content Placeholder 2"/>
+          <p:cNvSpPr>
+            <a:spLocks noGrp="1"/>
+          </p:cNvSpPr>
+          <p:nvPr>
+            <p:ph idx="1"/>
+          </p:nvPr>
+        </p:nvSpPr>
+        <p:spPr/>
+        <p:txBody>
+          <a:bodyPr wrap="square"/>
+          <a:lstStyle/>
+          <a:p>
+            <a:pPr>
+              <a:defRPr sz="2000"/>
+            </a:pPr>
+            <a:r>
+              <a:t>Définir avec tes mots : IA, modèle de langage et prompt.</a:t>
+            </a:r>
+          </a:p>
+          <a:p>
+            <a:pPr>
+              <a:defRPr sz="2000"/>
+            </a:pPr>
+            <a:r>
+              <a:t>Expliquer simplement comment un chatbot répond (il prédit le mot le plus probable à partir d'exemples).</a:t>
+            </a:r>
+          </a:p>
+          <a:p>
+            <a:pPr>
+              <a:defRPr sz="2000"/>
+            </a:pPr>
+            <a:r>
+              <a:t>Citer 5 usages de l'IA utiles à tes études (rechercher, résumer, rédiger, réviser, organiser).</a:t>
+            </a:r>
+          </a:p>
+          <a:p>
+            <a:pPr>
+              <a:defRPr sz="2000"/>
+            </a:pPr>
+            <a:r>
+              <a:t>Identifier 3 limites : erreurs, hallucinations, biais.</a:t>
+            </a:r>
+          </a:p>
+          <a:p>
+            <a:pPr>
+              <a:defRPr sz="2000"/>
+            </a:pPr>
+            <a:r>
+              <a:t>Appliquer les 3 règles d'or : vérifier, citer, garder ton jugement.</a:t>
+            </a:r>
+          </a:p>
+          <a:p/>
+          <a:p>
+            <a:pPr>
+              <a:defRPr sz="1300" i="1">
+                <a:solidFill>
+                  <a:srgbClr val="78899C"/>
+                </a:solidFill>
+              </a:defRPr>
+            </a:pPr>
+            <a:r>
+              <a:t>English summary:</a:t>
+            </a:r>
+          </a:p>
+          <a:p>
+            <a:pPr lvl="1">
+              <a:defRPr sz="1300">
+                <a:solidFill>
+                  <a:srgbClr val="546E7A"/>
+                </a:solidFill>
+              </a:defRPr>
+            </a:pPr>
+            <a:r>
+              <a:t>• Define in your own words: AI, language model and prompt.</a:t>
+            </a:r>
+          </a:p>
+          <a:p>
+            <a:pPr lvl="1">
+              <a:defRPr sz="1300">
+                <a:solidFill>
+                  <a:srgbClr val="546E7A"/>
+                </a:solidFill>
+              </a:defRPr>
+            </a:pPr>
+            <a:r>
+              <a:t>• Explain simply how a chatbot answers (it predicts the most probable word from examples).</a:t>
+            </a:r>
+          </a:p>
+          <a:p>
+            <a:pPr lvl="1">
+              <a:defRPr sz="1300">
+                <a:solidFill>
+                  <a:srgbClr val="546E7A"/>
+                </a:solidFill>
+              </a:defRPr>
+            </a:pPr>
+            <a:r>
+              <a:t>• List 5 AI uses helpful for your studies (search, summarise, write, revise, organise).</a:t>
+            </a:r>
+          </a:p>
+          <a:p>
+            <a:pPr lvl="1">
+              <a:defRPr sz="1300">
+                <a:solidFill>
+                  <a:srgbClr val="546E7A"/>
+                </a:solidFill>
+              </a:defRPr>
+            </a:pPr>
+            <a:r>
+              <a:t>• Identify 3 limits: errors, hallucinations, biases.</a:t>
+            </a:r>
+          </a:p>
+          <a:p>
+            <a:pPr lvl="1">
+              <a:defRPr sz="1300">
+                <a:solidFill>
+                  <a:srgbClr val="546E7A"/>
+                </a:solidFill>
+              </a:defRPr>
+            </a:pPr>
+            <a:r>
+              <a:t>• Apply the 3 golden rules: verify, cite, keep your judgement.</a:t>
             </a:r>
           </a:p>
         </p:txBody>
@@ -3903,133 +4201,173 @@
       <p:grpSpPr/>
       <p:sp>
         <p:nvSpPr>
-          <p:cNvPr id="2" name="TextBox 1"/>
-          <p:cNvSpPr txBox="1"/>
-          <p:nvPr/>
-        </p:nvSpPr>
-        <p:spPr>
-          <a:xfrm>
-            <a:off x="822960" y="502920"/>
-            <a:ext cx="10789920" cy="914400"/>
-          </a:xfrm>
-          <a:prstGeom prst="rect">
-            <a:avLst/>
-          </a:prstGeom>
-          <a:noFill/>
-        </p:spPr>
-        <p:txBody>
-          <a:bodyPr wrap="square">
-            <a:spAutoFit/>
-          </a:bodyPr>
-          <a:lstStyle/>
-          <a:p>
-            <a:r>
-              <a:rPr sz="3000" b="1" i="0">
-                <a:solidFill>
-                  <a:srgbClr val="177BBE"/>
-                </a:solidFill>
-              </a:rPr>
-              <a:t>(sans titre)</a:t>
-            </a:r>
-          </a:p>
-        </p:txBody>
-      </p:sp>
-      <p:sp>
-        <p:nvSpPr>
-          <p:cNvPr id="3" name="TextBox 2"/>
-          <p:cNvSpPr txBox="1"/>
-          <p:nvPr/>
-        </p:nvSpPr>
-        <p:spPr>
-          <a:xfrm>
-            <a:off x="822960" y="1463040"/>
-            <a:ext cx="10515600" cy="4937760"/>
-          </a:xfrm>
-          <a:prstGeom prst="rect">
-            <a:avLst/>
-          </a:prstGeom>
-          <a:noFill/>
-        </p:spPr>
-        <p:txBody>
-          <a:bodyPr wrap="square">
-            <a:spAutoFit/>
-          </a:bodyPr>
-          <a:lstStyle/>
-          <a:p>
-            <a:pPr/>
-            <a:r>
-              <a:rPr sz="2000" b="0" i="0">
-                <a:solidFill>
-                  <a:srgbClr val="263238"/>
-                </a:solidFill>
-              </a:rPr>
-              <a:t>• 🎯 Objectifs pédagogiques</a:t>
-            </a:r>
-          </a:p>
-          <a:p>
-            <a:pPr/>
-            <a:r>
-              <a:rPr sz="2000" b="0" i="0">
-                <a:solidFill>
-                  <a:srgbClr val="263238"/>
-                </a:solidFill>
-              </a:rPr>
-              <a:t>• Définir l'intelligence artificielle en une phrase compréhensible pour un enfant du primaire.</a:t>
-            </a:r>
-          </a:p>
-          <a:p>
-            <a:pPr/>
-            <a:r>
-              <a:rPr sz="2000" b="0" i="0">
-                <a:solidFill>
-                  <a:srgbClr val="263238"/>
-                </a:solidFill>
-              </a:rPr>
-              <a:t>• Citer au moins 3 exemples concrets d'IA rencontrés dans la vie quotidienne.</a:t>
-            </a:r>
-          </a:p>
-          <a:p>
-            <a:pPr/>
-            <a:r>
-              <a:rPr sz="2000" b="0" i="0">
-                <a:solidFill>
-                  <a:srgbClr val="263238"/>
-                </a:solidFill>
-              </a:rPr>
-              <a:t>• Distinguer l'IA faible, l'IA générale et l'hypothétique super-IA.</a:t>
-            </a:r>
-          </a:p>
-          <a:p>
-            <a:pPr/>
-            <a:r>
-              <a:rPr sz="2000" b="0" i="0">
-                <a:solidFill>
-                  <a:srgbClr val="263238"/>
-                </a:solidFill>
-              </a:rPr>
-              <a:t>• Identifier 3 usages de l'IA utiles à un enseignant de primaire (préparer des cours, différencier, évaluer).</a:t>
-            </a:r>
-          </a:p>
-          <a:p>
-            <a:pPr/>
-            <a:r>
-              <a:rPr sz="2000" b="0" i="0">
-                <a:solidFill>
-                  <a:srgbClr val="263238"/>
-                </a:solidFill>
-              </a:rPr>
-              <a:t>• Démystifier les idées fausses : l'IA ne « pense » pas comme un humain.</a:t>
-            </a:r>
-          </a:p>
-          <a:p>
-            <a:pPr/>
-            <a:r>
-              <a:rPr sz="2000" b="0" i="1">
-                <a:solidFill>
-                  <a:srgbClr val="263238"/>
-                </a:solidFill>
-              </a:rPr>
-              <a:t>• Objectifs en anglais : Define artificial intelligence in one sentence a primary-school child can understand.</a:t>
+          <p:cNvPr id="2" name="Title 1"/>
+          <p:cNvSpPr>
+            <a:spLocks noGrp="1"/>
+          </p:cNvSpPr>
+          <p:nvPr>
+            <p:ph type="title"/>
+          </p:nvPr>
+        </p:nvSpPr>
+        <p:spPr/>
+        <p:txBody>
+          <a:bodyPr/>
+          <a:lstStyle/>
+          <a:p>
+            <a:r>
+              <a:t>Déroulé pédagogique (1 h 30)</a:t>
+            </a:r>
+            <a:r>
+              <a:t>  ·  Session plan</a:t>
+            </a:r>
+          </a:p>
+        </p:txBody>
+      </p:sp>
+      <p:sp>
+        <p:nvSpPr>
+          <p:cNvPr id="3" name="Content Placeholder 2"/>
+          <p:cNvSpPr>
+            <a:spLocks noGrp="1"/>
+          </p:cNvSpPr>
+          <p:nvPr>
+            <p:ph idx="1"/>
+          </p:nvPr>
+        </p:nvSpPr>
+        <p:spPr/>
+        <p:txBody>
+          <a:bodyPr wrap="square"/>
+          <a:lstStyle/>
+          <a:p>
+            <a:pPr>
+              <a:defRPr sz="2000"/>
+            </a:pPr>
+            <a:r>
+              <a:t>00–05 — Accroche et sondage</a:t>
+            </a:r>
+          </a:p>
+          <a:p>
+            <a:pPr>
+              <a:defRPr sz="2000"/>
+            </a:pPr>
+            <a:r>
+              <a:t>05–20 — Explication pas à pas : 3 idées clés</a:t>
+            </a:r>
+          </a:p>
+          <a:p>
+            <a:pPr>
+              <a:defRPr sz="2000"/>
+            </a:pPr>
+            <a:r>
+              <a:t>20–40 — Démonstration : un résumé de cours</a:t>
+            </a:r>
+          </a:p>
+          <a:p>
+            <a:pPr>
+              <a:defRPr sz="2000"/>
+            </a:pPr>
+            <a:r>
+              <a:t>40–55 — Exercice guidé : vrai ou faux ?</a:t>
+            </a:r>
+          </a:p>
+          <a:p>
+            <a:pPr>
+              <a:defRPr sz="2000"/>
+            </a:pPr>
+            <a:r>
+              <a:t>55–60 — Résumé visuel et quiz éclair</a:t>
+            </a:r>
+          </a:p>
+          <a:p>
+            <a:pPr>
+              <a:defRPr sz="2000"/>
+            </a:pPr>
+            <a:r>
+              <a:t>60–90 — Atelier : dialogues et rôles</a:t>
+            </a:r>
+          </a:p>
+          <a:p/>
+          <a:p>
+            <a:pPr>
+              <a:defRPr sz="1300" i="1">
+                <a:solidFill>
+                  <a:srgbClr val="78899C"/>
+                </a:solidFill>
+              </a:defRPr>
+            </a:pPr>
+            <a:r>
+              <a:t>English summary:</a:t>
+            </a:r>
+          </a:p>
+          <a:p>
+            <a:pPr lvl="1">
+              <a:defRPr sz="1300">
+                <a:solidFill>
+                  <a:srgbClr val="546E7A"/>
+                </a:solidFill>
+              </a:defRPr>
+            </a:pPr>
+            <a:r>
+              <a:t>• Hook and survey</a:t>
+            </a:r>
+          </a:p>
+          <a:p>
+            <a:pPr lvl="1">
+              <a:defRPr sz="1300">
+                <a:solidFill>
+                  <a:srgbClr val="546E7A"/>
+                </a:solidFill>
+              </a:defRPr>
+            </a:pPr>
+            <a:r>
+              <a:t>• Step-by-step: 3 key ideas</a:t>
+            </a:r>
+          </a:p>
+          <a:p>
+            <a:pPr lvl="1">
+              <a:defRPr sz="1300">
+                <a:solidFill>
+                  <a:srgbClr val="546E7A"/>
+                </a:solidFill>
+              </a:defRPr>
+            </a:pPr>
+            <a:r>
+              <a:t>• Demonstration: a lesson summary</a:t>
+            </a:r>
+          </a:p>
+          <a:p>
+            <a:pPr lvl="1">
+              <a:defRPr sz="1300">
+                <a:solidFill>
+                  <a:srgbClr val="546E7A"/>
+                </a:solidFill>
+              </a:defRPr>
+            </a:pPr>
+            <a:r>
+              <a:t>• Guided exercise: true or false?</a:t>
+            </a:r>
+          </a:p>
+          <a:p>
+            <a:pPr lvl="1">
+              <a:defRPr sz="1300">
+                <a:solidFill>
+                  <a:srgbClr val="546E7A"/>
+                </a:solidFill>
+              </a:defRPr>
+            </a:pPr>
+            <a:r>
+              <a:t>• Visual summary and quick quiz</a:t>
+            </a:r>
+          </a:p>
+          <a:p>
+            <a:pPr lvl="1">
+              <a:defRPr sz="1300">
+                <a:solidFill>
+                  <a:srgbClr val="546E7A"/>
+                </a:solidFill>
+              </a:defRPr>
+            </a:pPr>
+            <a:r>
+              <a:t>• Workshop: dialogues and role-play</a:t>
             </a:r>
           </a:p>
         </p:txBody>
@@ -4054,111 +4392,89 @@
       <p:grpSpPr/>
       <p:sp>
         <p:nvSpPr>
-          <p:cNvPr id="2" name="TextBox 1"/>
-          <p:cNvSpPr txBox="1"/>
-          <p:nvPr/>
-        </p:nvSpPr>
-        <p:spPr>
-          <a:xfrm>
-            <a:off x="822960" y="502920"/>
-            <a:ext cx="10789920" cy="914400"/>
-          </a:xfrm>
-          <a:prstGeom prst="rect">
-            <a:avLst/>
-          </a:prstGeom>
-          <a:noFill/>
-        </p:spPr>
-        <p:txBody>
-          <a:bodyPr wrap="square">
-            <a:spAutoFit/>
-          </a:bodyPr>
-          <a:lstStyle/>
-          <a:p>
-            <a:r>
-              <a:rPr sz="3000" b="1" i="0">
-                <a:solidFill>
-                  <a:srgbClr val="177BBE"/>
-                </a:solidFill>
-              </a:rPr>
-              <a:t>(sans titre)</a:t>
-            </a:r>
-          </a:p>
-        </p:txBody>
-      </p:sp>
-      <p:sp>
-        <p:nvSpPr>
-          <p:cNvPr id="3" name="TextBox 2"/>
-          <p:cNvSpPr txBox="1"/>
-          <p:nvPr/>
-        </p:nvSpPr>
-        <p:spPr>
-          <a:xfrm>
-            <a:off x="822960" y="1463040"/>
-            <a:ext cx="10515600" cy="4937760"/>
-          </a:xfrm>
-          <a:prstGeom prst="rect">
-            <a:avLst/>
-          </a:prstGeom>
-          <a:noFill/>
-        </p:spPr>
-        <p:txBody>
-          <a:bodyPr wrap="square">
-            <a:spAutoFit/>
-          </a:bodyPr>
-          <a:lstStyle/>
-          <a:p>
-            <a:pPr/>
-            <a:r>
-              <a:rPr sz="2000" b="0" i="0">
-                <a:solidFill>
-                  <a:srgbClr val="263238"/>
-                </a:solidFill>
-              </a:rPr>
-              <a:t>• Qu'est-ce que l'Intelligence Artificielle ?</a:t>
-            </a:r>
-          </a:p>
-          <a:p>
-            <a:pPr/>
-            <a:r>
-              <a:rPr sz="2000" b="0" i="0">
-                <a:solidFill>
-                  <a:srgbClr val="263238"/>
-                </a:solidFill>
-              </a:rPr>
-              <a:t>• L'intelligence artificielle (IA) est un programme informatique qui apprend à partir de données pour reconnaître des formes, comprendre un langage ou prendre des décisions. Pour un enfant de primaire, on peut dire : « c'est un ordinateur qui apprend en regardant beaucoup d'exemples ». « Artificiel » signifie « fabriqué par l'homme », par opposition à l'intelligence naturelle des êtres vivants.</a:t>
-            </a:r>
-          </a:p>
-          <a:p>
-            <a:pPr/>
-            <a:r>
-              <a:rPr sz="2000" b="0" i="0">
-                <a:solidFill>
-                  <a:srgbClr val="263238"/>
-                </a:solidFill>
-              </a:rPr>
-              <a:t>• Trois mots-clés à retenir : les données (les exemples fournis), l'algorithme (la recette de calcul) et le modèle (le résultat de l'apprentissage, que l'on réutilise). Sans données, pas d'IA : c'est la matière première.</a:t>
-            </a:r>
-          </a:p>
-          <a:p>
-            <a:pPr/>
-            <a:r>
-              <a:rPr sz="2000" b="0" i="0">
-                <a:solidFill>
-                  <a:srgbClr val="263238"/>
-                </a:solidFill>
-              </a:rPr>
-              <a:t>• 💡 Def pour la classe : « L'IA, c'est comme un élève qui apprend d'abord en regardant plein d'exemples, puis qui devient capable de répondre tout seul. »</a:t>
-            </a:r>
-          </a:p>
-          <a:p>
-            <a:pPr/>
-            <a:r>
-              <a:rPr sz="2000" b="0" i="1">
-                <a:solidFill>
-                  <a:srgbClr val="263238"/>
-                </a:solidFill>
-              </a:rPr>
-              <a:t>• What is Artificial Intelligence?</a:t>
+          <p:cNvPr id="2" name="Title 1"/>
+          <p:cNvSpPr>
+            <a:spLocks noGrp="1"/>
+          </p:cNvSpPr>
+          <p:nvPr>
+            <p:ph type="title"/>
+          </p:nvPr>
+        </p:nvSpPr>
+        <p:spPr/>
+        <p:txBody>
+          <a:bodyPr/>
+          <a:lstStyle/>
+          <a:p>
+            <a:r>
+              <a:t>🎬 Accroche (5 min)</a:t>
+            </a:r>
+            <a:r>
+              <a:t>  ·  Hook</a:t>
+            </a:r>
+          </a:p>
+        </p:txBody>
+      </p:sp>
+      <p:sp>
+        <p:nvSpPr>
+          <p:cNvPr id="3" name="Content Placeholder 2"/>
+          <p:cNvSpPr>
+            <a:spLocks noGrp="1"/>
+          </p:cNvSpPr>
+          <p:nvPr>
+            <p:ph idx="1"/>
+          </p:nvPr>
+        </p:nvSpPr>
+        <p:spPr/>
+        <p:txBody>
+          <a:bodyPr wrap="square"/>
+          <a:lstStyle/>
+          <a:p>
+            <a:pPr>
+              <a:defRPr sz="2000"/>
+            </a:pPr>
+            <a:r>
+              <a:t>❓ Savez-vous que votre téléphone utilise l'IA des dizaines de fois par jour, sans que vous vous en rendiez compte ? Verrouillage du visage, traduction, correction du clavier, recommandation de vidéos…</a:t>
+            </a:r>
+          </a:p>
+          <a:p>
+            <a:pPr>
+              <a:defRPr sz="2000"/>
+            </a:pPr>
+            <a:r>
+              <a:t>🍳 🍳 L'IA, c'est comme un apprenti cuisinier : il goûte des milliers de plats (les exemples), remarque des régularités (le sucre c'est sucré, le citron c'est acide) et finit par pouvoir créer sa propre recette. Il ne sait pas POURQUOI ça marche, il a appris QUE ça marche.</a:t>
+            </a:r>
+          </a:p>
+          <a:p>
+            <a:pPr>
+              <a:defRPr sz="2000"/>
+            </a:pPr>
+            <a:r>
+              <a:t>💡 💡 L'IA, c'est un programme informatique qui apprend à partir d'exemples pour imiter certaines capacités humaines : comprendre, parler, traduire, voir, décider.</a:t>
+            </a:r>
+          </a:p>
+          <a:p/>
+          <a:p>
+            <a:pPr>
+              <a:defRPr sz="1300" i="1">
+                <a:solidFill>
+                  <a:srgbClr val="78899C"/>
+                </a:solidFill>
+              </a:defRPr>
+            </a:pPr>
+            <a:r>
+              <a:t>English summary:</a:t>
+            </a:r>
+          </a:p>
+          <a:p>
+            <a:pPr lvl="1">
+              <a:defRPr sz="1300">
+                <a:solidFill>
+                  <a:srgbClr val="546E7A"/>
+                </a:solidFill>
+              </a:defRPr>
+            </a:pPr>
+            <a:r>
+              <a:t>• 💡 AI is a computer program that learns from examples to imitate certain human abilities: understanding, speaking, translating, seeing, deciding.</a:t>
             </a:r>
           </a:p>
         </p:txBody>
@@ -4183,89 +4499,133 @@
       <p:grpSpPr/>
       <p:sp>
         <p:nvSpPr>
-          <p:cNvPr id="2" name="TextBox 1"/>
-          <p:cNvSpPr txBox="1"/>
-          <p:nvPr/>
-        </p:nvSpPr>
-        <p:spPr>
-          <a:xfrm>
-            <a:off x="822960" y="502920"/>
-            <a:ext cx="10789920" cy="914400"/>
-          </a:xfrm>
-          <a:prstGeom prst="rect">
-            <a:avLst/>
-          </a:prstGeom>
-          <a:noFill/>
-        </p:spPr>
-        <p:txBody>
-          <a:bodyPr wrap="square">
-            <a:spAutoFit/>
-          </a:bodyPr>
-          <a:lstStyle/>
-          <a:p>
-            <a:r>
-              <a:rPr sz="3000" b="1" i="0">
-                <a:solidFill>
-                  <a:srgbClr val="177BBE"/>
-                </a:solidFill>
-              </a:rPr>
-              <a:t>(sans titre)</a:t>
-            </a:r>
-          </a:p>
-        </p:txBody>
-      </p:sp>
-      <p:sp>
-        <p:nvSpPr>
-          <p:cNvPr id="3" name="TextBox 2"/>
-          <p:cNvSpPr txBox="1"/>
-          <p:nvPr/>
-        </p:nvSpPr>
-        <p:spPr>
-          <a:xfrm>
-            <a:off x="822960" y="1463040"/>
-            <a:ext cx="10515600" cy="4937760"/>
-          </a:xfrm>
-          <a:prstGeom prst="rect">
-            <a:avLst/>
-          </a:prstGeom>
-          <a:noFill/>
-        </p:spPr>
-        <p:txBody>
-          <a:bodyPr wrap="square">
-            <a:spAutoFit/>
-          </a:bodyPr>
-          <a:lstStyle/>
-          <a:p>
-            <a:pPr/>
-            <a:r>
-              <a:rPr sz="2000" b="0" i="0">
-                <a:solidFill>
-                  <a:srgbClr val="263238"/>
-                </a:solidFill>
-              </a:rPr>
-              <a:t>• Une petite histoire de l'IA (5 dates à connaître)</a:t>
-            </a:r>
-          </a:p>
-          <a:p>
-            <a:pPr/>
-            <a:r>
-              <a:rPr sz="2000" b="0" i="0">
-                <a:solidFill>
-                  <a:srgbClr val="263238"/>
-                </a:solidFill>
-              </a:rPr>
-              <a:t>• L'idée n'est pas neuve : dès les années 1950, les chercheurs rêvent de machines qui calculent et réfléchissent. Voici les dates clés à retenir pour expliquer l'IA à vos futurs élèves.</a:t>
-            </a:r>
-          </a:p>
-          <a:p>
-            <a:pPr/>
-            <a:r>
-              <a:rPr sz="2000" b="0" i="1">
-                <a:solidFill>
-                  <a:srgbClr val="263238"/>
-                </a:solidFill>
-              </a:rPr>
-              <a:t>• A short history of AI (5 dates to know)</a:t>
+          <p:cNvPr id="2" name="Title 1"/>
+          <p:cNvSpPr>
+            <a:spLocks noGrp="1"/>
+          </p:cNvSpPr>
+          <p:nvPr>
+            <p:ph type="title"/>
+          </p:nvPr>
+        </p:nvSpPr>
+        <p:spPr/>
+        <p:txBody>
+          <a:bodyPr/>
+          <a:lstStyle/>
+          <a:p>
+            <a:r>
+              <a:t>Idée clé 1 — L'IA apprend sur des exemples</a:t>
+            </a:r>
+            <a:r>
+              <a:t>  ·  Key idea 1 — AI learns from examples</a:t>
+            </a:r>
+          </a:p>
+        </p:txBody>
+      </p:sp>
+      <p:sp>
+        <p:nvSpPr>
+          <p:cNvPr id="3" name="Content Placeholder 2"/>
+          <p:cNvSpPr>
+            <a:spLocks noGrp="1"/>
+          </p:cNvSpPr>
+          <p:nvPr>
+            <p:ph idx="1"/>
+          </p:nvPr>
+        </p:nvSpPr>
+        <p:spPr/>
+        <p:txBody>
+          <a:bodyPr wrap="square"/>
+          <a:lstStyle/>
+          <a:p>
+            <a:pPr>
+              <a:defRPr sz="2000"/>
+            </a:pPr>
+            <a:r>
+              <a:t>Une IA n'est pas programmée « à la main » comme une calculatrice. On lui montre des milliers d'exemples, et elle en tire des régularités. C'est une énorme machine à généraliser.</a:t>
+            </a:r>
+          </a:p>
+          <a:p>
+            <a:pPr>
+              <a:defRPr sz="2000"/>
+            </a:pPr>
+            <a:r>
+              <a:t>&lt;strong&gt;Données d'entraînement :&lt;/strong&gt; les exemples qu'on montre à l'IA (textes, images, sons).</a:t>
+            </a:r>
+          </a:p>
+          <a:p>
+            <a:pPr>
+              <a:defRPr sz="2000"/>
+            </a:pPr>
+            <a:r>
+              <a:t>&lt;strong&gt;Modèle :&lt;/strong&gt; le résultat de l'apprentissage — un « cerveau » numérique qui généralise à partir des exemples.</a:t>
+            </a:r>
+          </a:p>
+          <a:p>
+            <a:pPr>
+              <a:defRPr sz="2000"/>
+            </a:pPr>
+            <a:r>
+              <a:t>&lt;strong&gt;Prédiction :&lt;/strong&gt; quand tu lui poses une question, il ne « cherche » pas la réponse : il la reconstruit à partir de ce qu'il a appris.</a:t>
+            </a:r>
+          </a:p>
+          <a:p/>
+          <a:p>
+            <a:pPr>
+              <a:defRPr sz="1300" i="1">
+                <a:solidFill>
+                  <a:srgbClr val="78899C"/>
+                </a:solidFill>
+              </a:defRPr>
+            </a:pPr>
+            <a:r>
+              <a:t>English summary:</a:t>
+            </a:r>
+          </a:p>
+          <a:p>
+            <a:pPr lvl="1">
+              <a:defRPr sz="1300">
+                <a:solidFill>
+                  <a:srgbClr val="546E7A"/>
+                </a:solidFill>
+              </a:defRPr>
+            </a:pPr>
+            <a:r>
+              <a:t>• AI is not hand-programmed like a calculator. We show it thousands of examples, and it extracts patterns. It is a huge generalisation machine.</a:t>
+            </a:r>
+          </a:p>
+          <a:p>
+            <a:pPr lvl="1">
+              <a:defRPr sz="1300">
+                <a:solidFill>
+                  <a:srgbClr val="546E7A"/>
+                </a:solidFill>
+              </a:defRPr>
+            </a:pPr>
+            <a:r>
+              <a:t>• &lt;strong&gt;Training data:&lt;/strong&gt; the examples shown to AI (texts, images, sounds).</a:t>
+            </a:r>
+          </a:p>
+          <a:p>
+            <a:pPr lvl="1">
+              <a:defRPr sz="1300">
+                <a:solidFill>
+                  <a:srgbClr val="546E7A"/>
+                </a:solidFill>
+              </a:defRPr>
+            </a:pPr>
+            <a:r>
+              <a:t>• &lt;strong&gt;Model:&lt;/strong&gt; the result of learning — a digital "brain" that generalises from examples.</a:t>
+            </a:r>
+          </a:p>
+          <a:p>
+            <a:pPr lvl="1">
+              <a:defRPr sz="1300">
+                <a:solidFill>
+                  <a:srgbClr val="546E7A"/>
+                </a:solidFill>
+              </a:defRPr>
+            </a:pPr>
+            <a:r>
+              <a:t>• &lt;strong&gt;Prediction:&lt;/strong&gt; when you ask a question, it does not "look up" the answer: it rebuilds it from what it learned.</a:t>
             </a:r>
           </a:p>
         </p:txBody>
@@ -4290,133 +4650,133 @@
       <p:grpSpPr/>
       <p:sp>
         <p:nvSpPr>
-          <p:cNvPr id="2" name="TextBox 1"/>
-          <p:cNvSpPr txBox="1"/>
-          <p:nvPr/>
-        </p:nvSpPr>
-        <p:spPr>
-          <a:xfrm>
-            <a:off x="822960" y="502920"/>
-            <a:ext cx="10789920" cy="914400"/>
-          </a:xfrm>
-          <a:prstGeom prst="rect">
-            <a:avLst/>
-          </a:prstGeom>
-          <a:noFill/>
-        </p:spPr>
-        <p:txBody>
-          <a:bodyPr wrap="square">
-            <a:spAutoFit/>
-          </a:bodyPr>
-          <a:lstStyle/>
-          <a:p>
-            <a:r>
-              <a:rPr sz="3000" b="1" i="0">
-                <a:solidFill>
-                  <a:srgbClr val="177BBE"/>
-                </a:solidFill>
-              </a:rPr>
-              <a:t>(sans titre)</a:t>
-            </a:r>
-          </a:p>
-        </p:txBody>
-      </p:sp>
-      <p:sp>
-        <p:nvSpPr>
-          <p:cNvPr id="3" name="TextBox 2"/>
-          <p:cNvSpPr txBox="1"/>
-          <p:nvPr/>
-        </p:nvSpPr>
-        <p:spPr>
-          <a:xfrm>
-            <a:off x="822960" y="1463040"/>
-            <a:ext cx="10515600" cy="4937760"/>
-          </a:xfrm>
-          <a:prstGeom prst="rect">
-            <a:avLst/>
-          </a:prstGeom>
-          <a:noFill/>
-        </p:spPr>
-        <p:txBody>
-          <a:bodyPr wrap="square">
-            <a:spAutoFit/>
-          </a:bodyPr>
-          <a:lstStyle/>
-          <a:p>
-            <a:pPr/>
-            <a:r>
-              <a:rPr sz="2000" b="0" i="0">
-                <a:solidFill>
-                  <a:srgbClr val="263238"/>
-                </a:solidFill>
-              </a:rPr>
-              <a:t>• Les 3 grandes familles d'IA</a:t>
-            </a:r>
-          </a:p>
-          <a:p>
-            <a:pPr/>
-            <a:r>
-              <a:rPr sz="2000" b="0" i="0">
-                <a:solidFill>
-                  <a:srgbClr val="263238"/>
-                </a:solidFill>
-              </a:rPr>
-              <a:t>• On distingue trois niveaux d'IA. Aujourd'hui, tout ce que nous utilisons est de l'IA faible (appelée aussi « étroite ») : elle excelle dans une seule tâche précise.</a:t>
-            </a:r>
-          </a:p>
-          <a:p>
-            <a:pPr/>
-            <a:r>
-              <a:rPr sz="2000" b="0" i="0">
-                <a:solidFill>
-                  <a:srgbClr val="263238"/>
-                </a:solidFill>
-              </a:rPr>
-              <a:t>• IA faible (étroite) : une seule tâche — traduction, reconnaissance d'images, filtrage des spams… Excellente dans son domaine, mais inutile ailleurs.</a:t>
-            </a:r>
-          </a:p>
-          <a:p>
-            <a:pPr/>
-            <a:r>
-              <a:rPr sz="2000" b="0" i="0">
-                <a:solidFill>
-                  <a:srgbClr val="263238"/>
-                </a:solidFill>
-              </a:rPr>
-              <a:t>• IA générale : égalerait un humain dans toutes les tâches intellectuelles. N'existe pas encore, c'est un objectif de recherche.</a:t>
-            </a:r>
-          </a:p>
-          <a:p>
-            <a:pPr/>
-            <a:r>
-              <a:rPr sz="2000" b="0" i="0">
-                <a:solidFill>
-                  <a:srgbClr val="263238"/>
-                </a:solidFill>
-              </a:rPr>
-              <a:t>• Super-IA : dépasserait l'intelligence humaine. C'est un scénario hypothétique (science-fiction pour l'instant, mais qui nourrit les débats éthiques).</a:t>
-            </a:r>
-          </a:p>
-          <a:p>
-            <a:pPr/>
-            <a:r>
-              <a:rPr sz="2000" b="0" i="0">
-                <a:solidFill>
-                  <a:srgbClr val="263238"/>
-                </a:solidFill>
-              </a:rPr>
-              <a:t>• 💡 Astuce de formateur : utilisez l'image de la boîte à outils — « l'IA faible, ce sont des outils spécialisés, pas un couteau suisse magique ».</a:t>
-            </a:r>
-          </a:p>
-          <a:p>
-            <a:pPr/>
-            <a:r>
-              <a:rPr sz="2000" b="0" i="1">
-                <a:solidFill>
-                  <a:srgbClr val="263238"/>
-                </a:solidFill>
-              </a:rPr>
-              <a:t>• The three main families of AI</a:t>
+          <p:cNvPr id="2" name="Title 1"/>
+          <p:cNvSpPr>
+            <a:spLocks noGrp="1"/>
+          </p:cNvSpPr>
+          <p:nvPr>
+            <p:ph type="title"/>
+          </p:nvPr>
+        </p:nvSpPr>
+        <p:spPr/>
+        <p:txBody>
+          <a:bodyPr/>
+          <a:lstStyle/>
+          <a:p>
+            <a:r>
+              <a:t>Idée clé 2 — Un chatbot prédit le mot suivant</a:t>
+            </a:r>
+            <a:r>
+              <a:t>  ·  Key idea 2 — A chatbot predicts the next word</a:t>
+            </a:r>
+          </a:p>
+        </p:txBody>
+      </p:sp>
+      <p:sp>
+        <p:nvSpPr>
+          <p:cNvPr id="3" name="Content Placeholder 2"/>
+          <p:cNvSpPr>
+            <a:spLocks noGrp="1"/>
+          </p:cNvSpPr>
+          <p:nvPr>
+            <p:ph idx="1"/>
+          </p:nvPr>
+        </p:nvSpPr>
+        <p:spPr/>
+        <p:txBody>
+          <a:bodyPr wrap="square"/>
+          <a:lstStyle/>
+          <a:p>
+            <a:pPr>
+              <a:defRPr sz="2000"/>
+            </a:pPr>
+            <a:r>
+              <a:t>ChatGPT, Gemini ou Copilot sont des « modèles de langage » (LLM). Leur secret : ils ont été entraînés sur des milliards de phrases, et ils ont appris une seule chose — quel mot vient le plus probablement après celui-ci.</a:t>
+            </a:r>
+          </a:p>
+          <a:p>
+            <a:pPr>
+              <a:defRPr sz="2000"/>
+            </a:pPr>
+            <a:r>
+              <a:t>« Hier, je suis allé … » → le modèle propose « au marché » parce que c'est très fréquent dans ses données.</a:t>
+            </a:r>
+          </a:p>
+          <a:p>
+            <a:pPr>
+              <a:defRPr sz="2000"/>
+            </a:pPr>
+            <a:r>
+              <a:t>Il génère mot après mot, jusqu'à former une phrase entière. Résultat : un texte qui paraît très naturel.</a:t>
+            </a:r>
+          </a:p>
+          <a:p>
+            <a:pPr>
+              <a:defRPr sz="2000"/>
+            </a:pPr>
+            <a:r>
+              <a:t>Il est entraîné à être &lt;strong&gt;convaincant&lt;/strong&gt;, pas à être &lt;strong&gt;vrai&lt;/strong&gt;. D'où les erreurs et les hallucinations.</a:t>
+            </a:r>
+          </a:p>
+          <a:p/>
+          <a:p>
+            <a:pPr>
+              <a:defRPr sz="1300" i="1">
+                <a:solidFill>
+                  <a:srgbClr val="78899C"/>
+                </a:solidFill>
+              </a:defRPr>
+            </a:pPr>
+            <a:r>
+              <a:t>English summary:</a:t>
+            </a:r>
+          </a:p>
+          <a:p>
+            <a:pPr lvl="1">
+              <a:defRPr sz="1300">
+                <a:solidFill>
+                  <a:srgbClr val="546E7A"/>
+                </a:solidFill>
+              </a:defRPr>
+            </a:pPr>
+            <a:r>
+              <a:t>• ChatGPT, Gemini or Copilot are "language models" (LLMs). Their secret: they were trained on billions of sentences, and they learned one thing — which word most probably comes after this one.</a:t>
+            </a:r>
+          </a:p>
+          <a:p>
+            <a:pPr lvl="1">
+              <a:defRPr sz="1300">
+                <a:solidFill>
+                  <a:srgbClr val="546E7A"/>
+                </a:solidFill>
+              </a:defRPr>
+            </a:pPr>
+            <a:r>
+              <a:t>• "Yesterday I went to …" → the model suggests "the market" because it is very frequent in its data.</a:t>
+            </a:r>
+          </a:p>
+          <a:p>
+            <a:pPr lvl="1">
+              <a:defRPr sz="1300">
+                <a:solidFill>
+                  <a:srgbClr val="546E7A"/>
+                </a:solidFill>
+              </a:defRPr>
+            </a:pPr>
+            <a:r>
+              <a:t>• It generates word after word, until a whole sentence forms. Result: text that looks very natural.</a:t>
+            </a:r>
+          </a:p>
+          <a:p>
+            <a:pPr lvl="1">
+              <a:defRPr sz="1300">
+                <a:solidFill>
+                  <a:srgbClr val="546E7A"/>
+                </a:solidFill>
+              </a:defRPr>
+            </a:pPr>
+            <a:r>
+              <a:t>• It is trained to be &lt;strong&gt;convincing&lt;/strong&gt;, not &lt;strong&gt;true&lt;/strong&gt;. Hence errors and hallucinations.</a:t>
             </a:r>
           </a:p>
         </p:txBody>
@@ -4441,144 +4801,133 @@
       <p:grpSpPr/>
       <p:sp>
         <p:nvSpPr>
-          <p:cNvPr id="2" name="TextBox 1"/>
-          <p:cNvSpPr txBox="1"/>
-          <p:nvPr/>
-        </p:nvSpPr>
-        <p:spPr>
-          <a:xfrm>
-            <a:off x="822960" y="502920"/>
-            <a:ext cx="10789920" cy="914400"/>
-          </a:xfrm>
-          <a:prstGeom prst="rect">
-            <a:avLst/>
-          </a:prstGeom>
-          <a:noFill/>
-        </p:spPr>
-        <p:txBody>
-          <a:bodyPr wrap="square">
-            <a:spAutoFit/>
-          </a:bodyPr>
-          <a:lstStyle/>
-          <a:p>
-            <a:r>
-              <a:rPr sz="3000" b="1" i="0">
-                <a:solidFill>
-                  <a:srgbClr val="177BBE"/>
-                </a:solidFill>
-              </a:rPr>
-              <a:t>(sans titre)</a:t>
-            </a:r>
-          </a:p>
-        </p:txBody>
-      </p:sp>
-      <p:sp>
-        <p:nvSpPr>
-          <p:cNvPr id="3" name="TextBox 2"/>
-          <p:cNvSpPr txBox="1"/>
-          <p:nvPr/>
-        </p:nvSpPr>
-        <p:spPr>
-          <a:xfrm>
-            <a:off x="822960" y="1463040"/>
-            <a:ext cx="10515600" cy="4937760"/>
-          </a:xfrm>
-          <a:prstGeom prst="rect">
-            <a:avLst/>
-          </a:prstGeom>
-          <a:noFill/>
-        </p:spPr>
-        <p:txBody>
-          <a:bodyPr wrap="square">
-            <a:spAutoFit/>
-          </a:bodyPr>
-          <a:lstStyle/>
-          <a:p>
-            <a:pPr/>
-            <a:r>
-              <a:rPr sz="2000" b="0" i="0">
-                <a:solidFill>
-                  <a:srgbClr val="263238"/>
-                </a:solidFill>
-              </a:rPr>
-              <a:t>• L'IA dans la vie quotidienne (exemples concrets)</a:t>
-            </a:r>
-          </a:p>
-          <a:p>
-            <a:pPr/>
-            <a:r>
-              <a:rPr sz="2000" b="0" i="0">
-                <a:solidFill>
-                  <a:srgbClr val="263238"/>
-                </a:solidFill>
-              </a:rPr>
-              <a:t>• Vos étudiants utilisent de l'IA sans le savoir, plusieurs fois par jour. Demandez-leur de citer des exemples avant de montrer cette liste.</a:t>
-            </a:r>
-          </a:p>
-          <a:p>
-            <a:pPr/>
-            <a:r>
-              <a:rPr sz="2000" b="0" i="0">
-                <a:solidFill>
-                  <a:srgbClr val="263238"/>
-                </a:solidFill>
-              </a:rPr>
-              <a:t>• Le GPS qui choisit le chemin le plus rapide (prédiction du trafic).</a:t>
-            </a:r>
-          </a:p>
-          <a:p>
-            <a:pPr/>
-            <a:r>
-              <a:rPr sz="2000" b="0" i="0">
-                <a:solidFill>
-                  <a:srgbClr val="263238"/>
-                </a:solidFill>
-              </a:rPr>
-              <a:t>• Le fil anti-spam de l'e-mail (classement des messages).</a:t>
-            </a:r>
-          </a:p>
-          <a:p>
-            <a:pPr/>
-            <a:r>
-              <a:rPr sz="2000" b="0" i="0">
-                <a:solidFill>
-                  <a:srgbClr val="263238"/>
-                </a:solidFill>
-              </a:rPr>
-              <a:t>• Netflix / YouTube : suggestions « parce que vous avez regardé… » (moteur de recommandation).</a:t>
-            </a:r>
-          </a:p>
-          <a:p>
-            <a:pPr/>
-            <a:r>
-              <a:rPr sz="2000" b="0" i="0">
-                <a:solidFill>
-                  <a:srgbClr val="263238"/>
-                </a:solidFill>
-              </a:rPr>
-              <a:t>• La reconnaissance faciale pour déverrouiller le téléphone.</a:t>
-            </a:r>
-          </a:p>
-          <a:p>
-            <a:pPr/>
-            <a:r>
-              <a:rPr sz="2000" b="0" i="0">
-                <a:solidFill>
-                  <a:srgbClr val="263238"/>
-                </a:solidFill>
-              </a:rPr>
-              <a:t>• Les assistants vocaux (Siri, Google Assistant) qui comprennent la parole.</a:t>
-            </a:r>
-          </a:p>
-          <a:p>
-            <a:pPr/>
-            <a:r>
-              <a:rPr sz="2000" b="0" i="1">
-                <a:solidFill>
-                  <a:srgbClr val="263238"/>
-                </a:solidFill>
-              </a:rPr>
-              <a:t>• AI in everyday life (concrete examples)</a:t>
+          <p:cNvPr id="2" name="Title 1"/>
+          <p:cNvSpPr>
+            <a:spLocks noGrp="1"/>
+          </p:cNvSpPr>
+          <p:nvPr>
+            <p:ph type="title"/>
+          </p:nvPr>
+        </p:nvSpPr>
+        <p:spPr/>
+        <p:txBody>
+          <a:bodyPr/>
+          <a:lstStyle/>
+          <a:p>
+            <a:r>
+              <a:t>Idée clé 3 — Trois familles d'IA</a:t>
+            </a:r>
+            <a:r>
+              <a:t>  ·  Key idea 3 — Three families of AI</a:t>
+            </a:r>
+          </a:p>
+        </p:txBody>
+      </p:sp>
+      <p:sp>
+        <p:nvSpPr>
+          <p:cNvPr id="3" name="Content Placeholder 2"/>
+          <p:cNvSpPr>
+            <a:spLocks noGrp="1"/>
+          </p:cNvSpPr>
+          <p:nvPr>
+            <p:ph idx="1"/>
+          </p:nvPr>
+        </p:nvSpPr>
+        <p:spPr/>
+        <p:txBody>
+          <a:bodyPr wrap="square"/>
+          <a:lstStyle/>
+          <a:p>
+            <a:pPr>
+              <a:defRPr sz="2000"/>
+            </a:pPr>
+            <a:r>
+              <a:t>Il faut savoir classer ce dont on parle : tout ce que tu utilises aujourd'hui appartient à la première famille.</a:t>
+            </a:r>
+          </a:p>
+          <a:p>
+            <a:pPr>
+              <a:defRPr sz="2000"/>
+            </a:pPr>
+            <a:r>
+              <a:t>&lt;strong&gt;1. IA faible (étroite)&lt;/strong&gt; : excellente dans UNE tâche (traduire, trier, générer du texte). → Tout ce qui existe aujourd'hui.</a:t>
+            </a:r>
+          </a:p>
+          <a:p>
+            <a:pPr>
+              <a:defRPr sz="2000"/>
+            </a:pPr>
+            <a:r>
+              <a:t>&lt;strong&gt;2. IA générale&lt;/strong&gt; : égalerait l'humain dans TOUTES les tâches. → N'existe pas encore.</a:t>
+            </a:r>
+          </a:p>
+          <a:p>
+            <a:pPr>
+              <a:defRPr sz="2000"/>
+            </a:pPr>
+            <a:r>
+              <a:t>&lt;strong&gt;3. Super-IA&lt;/strong&gt; : dépasserait l'humain. → Scénario hypothétique qui alimente les films et les débats.</a:t>
+            </a:r>
+          </a:p>
+          <a:p/>
+          <a:p>
+            <a:pPr>
+              <a:defRPr sz="1300" i="1">
+                <a:solidFill>
+                  <a:srgbClr val="78899C"/>
+                </a:solidFill>
+              </a:defRPr>
+            </a:pPr>
+            <a:r>
+              <a:t>English summary:</a:t>
+            </a:r>
+          </a:p>
+          <a:p>
+            <a:pPr lvl="1">
+              <a:defRPr sz="1300">
+                <a:solidFill>
+                  <a:srgbClr val="546E7A"/>
+                </a:solidFill>
+              </a:defRPr>
+            </a:pPr>
+            <a:r>
+              <a:t>• You should know how to classify what we talk about: everything you use today belongs to the first family.</a:t>
+            </a:r>
+          </a:p>
+          <a:p>
+            <a:pPr lvl="1">
+              <a:defRPr sz="1300">
+                <a:solidFill>
+                  <a:srgbClr val="546E7A"/>
+                </a:solidFill>
+              </a:defRPr>
+            </a:pPr>
+            <a:r>
+              <a:t>• &lt;strong&gt;1. Narrow AI&lt;/strong&gt;: excellent at ONE task (translating, sorting, generating text). → Everything that exists today.</a:t>
+            </a:r>
+          </a:p>
+          <a:p>
+            <a:pPr lvl="1">
+              <a:defRPr sz="1300">
+                <a:solidFill>
+                  <a:srgbClr val="546E7A"/>
+                </a:solidFill>
+              </a:defRPr>
+            </a:pPr>
+            <a:r>
+              <a:t>• &lt;strong&gt;2. General AI&lt;/strong&gt;: would equal humans at ALL tasks. → Does not exist yet.</a:t>
+            </a:r>
+          </a:p>
+          <a:p>
+            <a:pPr lvl="1">
+              <a:defRPr sz="1300">
+                <a:solidFill>
+                  <a:srgbClr val="546E7A"/>
+                </a:solidFill>
+              </a:defRPr>
+            </a:pPr>
+            <a:r>
+              <a:t>• &lt;strong&gt;3. Super-intelligence&lt;/strong&gt;: would surpass humans. → Hypothetical scenario that fuels films and debates.</a:t>
             </a:r>
           </a:p>
         </p:txBody>
@@ -4603,122 +4952,73 @@
       <p:grpSpPr/>
       <p:sp>
         <p:nvSpPr>
-          <p:cNvPr id="2" name="TextBox 1"/>
-          <p:cNvSpPr txBox="1"/>
-          <p:nvPr/>
-        </p:nvSpPr>
-        <p:spPr>
-          <a:xfrm>
-            <a:off x="822960" y="502920"/>
-            <a:ext cx="10789920" cy="914400"/>
-          </a:xfrm>
-          <a:prstGeom prst="rect">
-            <a:avLst/>
-          </a:prstGeom>
-          <a:noFill/>
-        </p:spPr>
-        <p:txBody>
-          <a:bodyPr wrap="square">
-            <a:spAutoFit/>
-          </a:bodyPr>
-          <a:lstStyle/>
-          <a:p>
-            <a:r>
-              <a:rPr sz="3000" b="1" i="0">
-                <a:solidFill>
-                  <a:srgbClr val="177BBE"/>
-                </a:solidFill>
-              </a:rPr>
-              <a:t>(sans titre)</a:t>
-            </a:r>
-          </a:p>
-        </p:txBody>
-      </p:sp>
-      <p:sp>
-        <p:nvSpPr>
-          <p:cNvPr id="3" name="TextBox 2"/>
-          <p:cNvSpPr txBox="1"/>
-          <p:nvPr/>
-        </p:nvSpPr>
-        <p:spPr>
-          <a:xfrm>
-            <a:off x="822960" y="1463040"/>
-            <a:ext cx="10515600" cy="4937760"/>
-          </a:xfrm>
-          <a:prstGeom prst="rect">
-            <a:avLst/>
-          </a:prstGeom>
-          <a:noFill/>
-        </p:spPr>
-        <p:txBody>
-          <a:bodyPr wrap="square">
-            <a:spAutoFit/>
-          </a:bodyPr>
-          <a:lstStyle/>
-          <a:p>
-            <a:pPr/>
-            <a:r>
-              <a:rPr sz="2000" b="0" i="0">
-                <a:solidFill>
-                  <a:srgbClr val="263238"/>
-                </a:solidFill>
-              </a:rPr>
-              <a:t>• Ce que l'IA sait faire… et ne sait pas faire</a:t>
-            </a:r>
-          </a:p>
-          <a:p>
-            <a:pPr/>
-            <a:r>
-              <a:rPr sz="2000" b="0" i="0">
-                <a:solidFill>
-                  <a:srgbClr val="263238"/>
-                </a:solidFill>
-              </a:rPr>
-              <a:t>• ✅ Ce qu'elle fait bien : résumer un texte, traduire, générer une image ou un exercice, corriger l'orthographe, adapter un texte à un niveau de lecture, produire une première version de fiche.</a:t>
-            </a:r>
-          </a:p>
-          <a:p>
-            <a:pPr/>
-            <a:r>
-              <a:rPr sz="2000" b="0" i="0">
-                <a:solidFill>
-                  <a:srgbClr val="263238"/>
-                </a:solidFill>
-              </a:rPr>
-              <a:t>• ⚠️ Ce qu'il faut vérifier : elle peut se tromper (« hallucination » : inventer des faits avec assurance), copier des biais présents dans ses données, et mélanger les langues.</a:t>
-            </a:r>
-          </a:p>
-          <a:p>
-            <a:pPr/>
-            <a:r>
-              <a:rPr sz="2000" b="0" i="0">
-                <a:solidFill>
-                  <a:srgbClr val="263238"/>
-                </a:solidFill>
-              </a:rPr>
-              <a:t>• ❌ Ce qu'elle ne fait pas : elle ne comprend pas réellement le sens, n'a pas d'intention, n'a pas d'émotions et n'est pas « responsable » de ses réponses.</a:t>
-            </a:r>
-          </a:p>
-          <a:p>
-            <a:pPr/>
-            <a:r>
-              <a:rPr sz="2000" b="0" i="0">
-                <a:solidFill>
-                  <a:srgbClr val="263238"/>
-                </a:solidFill>
-              </a:rPr>
-              <a:t>• 💡 Règle d'or pour l'enseignant : on ne met jamais un outil d'IA entre un élève et son apprentissage sans vérifier et sans garder son regard de professionnel. L'IA propose, l'enseignant dispose.</a:t>
-            </a:r>
-          </a:p>
-          <a:p>
-            <a:pPr/>
-            <a:r>
-              <a:rPr sz="2000" b="0" i="1">
-                <a:solidFill>
-                  <a:srgbClr val="263238"/>
-                </a:solidFill>
-              </a:rPr>
-              <a:t>• What AI can do… and cannot do</a:t>
+          <p:cNvPr id="2" name="Title 1"/>
+          <p:cNvSpPr>
+            <a:spLocks noGrp="1"/>
+          </p:cNvSpPr>
+          <p:nvPr>
+            <p:ph type="title"/>
+          </p:nvPr>
+        </p:nvSpPr>
+        <p:spPr/>
+        <p:txBody>
+          <a:bodyPr/>
+          <a:lstStyle/>
+          <a:p>
+            <a:r>
+              <a:t>Démonstration — un résumé de cours, du mauvais au bon prompt</a:t>
+            </a:r>
+            <a:r>
+              <a:t>  ·  Demonstration — a course summary, from bad to good prompt</a:t>
+            </a:r>
+          </a:p>
+        </p:txBody>
+      </p:sp>
+      <p:sp>
+        <p:nvSpPr>
+          <p:cNvPr id="3" name="Content Placeholder 2"/>
+          <p:cNvSpPr>
+            <a:spLocks noGrp="1"/>
+          </p:cNvSpPr>
+          <p:nvPr>
+            <p:ph idx="1"/>
+          </p:nvPr>
+        </p:nvSpPr>
+        <p:spPr/>
+        <p:txBody>
+          <a:bodyPr wrap="square"/>
+          <a:lstStyle/>
+          <a:p>
+            <a:pPr>
+              <a:defRPr sz="2000"/>
+            </a:pPr>
+            <a:r>
+              <a:t>Étudiant : « Je dois préparer mon exposé de psychologie de l'enfant. Je colle mon cours et je demande à l'IA de l'aider. » Regardons la différence entre une question paresseuse et une question qui guide.</a:t>
+            </a:r>
+          </a:p>
+          <a:p/>
+          <a:p>
+            <a:pPr>
+              <a:defRPr sz="1300" i="1">
+                <a:solidFill>
+                  <a:srgbClr val="78899C"/>
+                </a:solidFill>
+              </a:defRPr>
+            </a:pPr>
+            <a:r>
+              <a:t>English summary:</a:t>
+            </a:r>
+          </a:p>
+          <a:p>
+            <a:pPr lvl="1">
+              <a:defRPr sz="1300">
+                <a:solidFill>
+                  <a:srgbClr val="546E7A"/>
+                </a:solidFill>
+              </a:defRPr>
+            </a:pPr>
+            <a:r>
+              <a:t>• Student: "I must prepare my child-psychology presentation. I paste my lesson and ask AI to help." Look at the difference between a lazy question and a guiding one.</a:t>
             </a:r>
           </a:p>
         </p:txBody>
@@ -4743,133 +5043,141 @@
       <p:grpSpPr/>
       <p:sp>
         <p:nvSpPr>
-          <p:cNvPr id="2" name="TextBox 1"/>
-          <p:cNvSpPr txBox="1"/>
-          <p:nvPr/>
-        </p:nvSpPr>
-        <p:spPr>
-          <a:xfrm>
-            <a:off x="822960" y="502920"/>
-            <a:ext cx="10789920" cy="914400"/>
-          </a:xfrm>
-          <a:prstGeom prst="rect">
-            <a:avLst/>
-          </a:prstGeom>
-          <a:noFill/>
-        </p:spPr>
-        <p:txBody>
-          <a:bodyPr wrap="square">
-            <a:spAutoFit/>
-          </a:bodyPr>
-          <a:lstStyle/>
-          <a:p>
-            <a:r>
-              <a:rPr sz="3000" b="1" i="0">
-                <a:solidFill>
-                  <a:srgbClr val="177BBE"/>
-                </a:solidFill>
-              </a:rPr>
-              <a:t>(sans titre)</a:t>
-            </a:r>
-          </a:p>
-        </p:txBody>
-      </p:sp>
-      <p:sp>
-        <p:nvSpPr>
-          <p:cNvPr id="3" name="TextBox 2"/>
-          <p:cNvSpPr txBox="1"/>
-          <p:nvPr/>
-        </p:nvSpPr>
-        <p:spPr>
-          <a:xfrm>
-            <a:off x="822960" y="1463040"/>
-            <a:ext cx="10515600" cy="4937760"/>
-          </a:xfrm>
-          <a:prstGeom prst="rect">
-            <a:avLst/>
-          </a:prstGeom>
-          <a:noFill/>
-        </p:spPr>
-        <p:txBody>
-          <a:bodyPr wrap="square">
-            <a:spAutoFit/>
-          </a:bodyPr>
-          <a:lstStyle/>
-          <a:p>
-            <a:pPr/>
-            <a:r>
-              <a:rPr sz="2000" b="0" i="0">
-                <a:solidFill>
-                  <a:srgbClr val="263238"/>
-                </a:solidFill>
-              </a:rPr>
-              <a:t>• Pourquoi cela concerne le futur enseignant du primaire ?</a:t>
-            </a:r>
-          </a:p>
-          <a:p>
-            <a:pPr/>
-            <a:r>
-              <a:rPr sz="2000" b="0" i="0">
-                <a:solidFill>
-                  <a:srgbClr val="263238"/>
-                </a:solidFill>
-              </a:rPr>
-              <a:t>• Trois raisons principales, qui seront développées dans les séances 2 à 9 de ce module :</a:t>
-            </a:r>
-          </a:p>
-          <a:p>
-            <a:pPr/>
-            <a:r>
-              <a:rPr sz="2000" b="0" i="0">
-                <a:solidFill>
-                  <a:srgbClr val="263238"/>
-                </a:solidFill>
-              </a:rPr>
-              <a:t>• Gagner du temps : préparer une fiche de lecture, un QCM ou un exemple adapté en quelques minutes au lieu d'une heure.</a:t>
-            </a:r>
-          </a:p>
-          <a:p>
-            <a:pPr/>
-            <a:r>
-              <a:rPr sz="2000" b="0" i="0">
-                <a:solidFill>
-                  <a:srgbClr val="263238"/>
-                </a:solidFill>
-              </a:rPr>
-              <a:t>• Différencier : proposer une version simplifiée ou enrichie du même exercice pour chaque élève.</a:t>
-            </a:r>
-          </a:p>
-          <a:p>
-            <a:pPr/>
-            <a:r>
-              <a:rPr sz="2000" b="0" i="0">
-                <a:solidFill>
-                  <a:srgbClr val="263238"/>
-                </a:solidFill>
-              </a:rPr>
-              <a:t>• Eduquer aux médias : vos élèves grandiront avec l'IA ; ils doivent apprendre ce que c'est, et comment l'utiliser avec esprit critique.</a:t>
-            </a:r>
-          </a:p>
-          <a:p>
-            <a:pPr/>
-            <a:r>
-              <a:rPr sz="2000" b="0" i="0">
-                <a:solidFill>
-                  <a:srgbClr val="263238"/>
-                </a:solidFill>
-              </a:rPr>
-              <a:t>• 💡 Exemple pour la classe (à partager en séance 6) : un énoncé de problème de maths reformulé « avec des dinosaures » grâce à l'IA, pour motiver un élève réticent.</a:t>
-            </a:r>
-          </a:p>
-          <a:p>
-            <a:pPr/>
-            <a:r>
-              <a:rPr sz="2000" b="0" i="1">
-                <a:solidFill>
-                  <a:srgbClr val="263238"/>
-                </a:solidFill>
-              </a:rPr>
-              <a:t>• Why this matters for the future primary teacher</a:t>
+          <p:cNvPr id="2" name="Title 1"/>
+          <p:cNvSpPr>
+            <a:spLocks noGrp="1"/>
+          </p:cNvSpPr>
+          <p:nvPr>
+            <p:ph type="title"/>
+          </p:nvPr>
+        </p:nvSpPr>
+        <p:spPr/>
+        <p:txBody>
+          <a:bodyPr/>
+          <a:lstStyle/>
+          <a:p>
+            <a:r>
+              <a:t>Comment en profiter au maximum</a:t>
+            </a:r>
+            <a:r>
+              <a:t>  ·  How to get the most out of it</a:t>
+            </a:r>
+          </a:p>
+        </p:txBody>
+      </p:sp>
+      <p:sp>
+        <p:nvSpPr>
+          <p:cNvPr id="3" name="Content Placeholder 2"/>
+          <p:cNvSpPr>
+            <a:spLocks noGrp="1"/>
+          </p:cNvSpPr>
+          <p:nvPr>
+            <p:ph idx="1"/>
+          </p:nvPr>
+        </p:nvSpPr>
+        <p:spPr/>
+        <p:txBody>
+          <a:bodyPr wrap="square"/>
+          <a:lstStyle/>
+          <a:p>
+            <a:pPr>
+              <a:defRPr sz="2000"/>
+            </a:pPr>
+            <a:r>
+              <a:t>Dès la première séance, retenez l'essentiel : l'IA vaut ce que vaut la question posée, et la réponse vaut ce que vaut la vérification. Utilisée ainsi, elle devient un tuteur personnel disponible 24 h/24 — jamais un remplaçant de ta mémoire.</a:t>
+            </a:r>
+          </a:p>
+          <a:p>
+            <a:pPr>
+              <a:defRPr sz="2000"/>
+            </a:pPr>
+            <a:r>
+              <a:t>&lt;strong&gt;✅ Commencez petit :&lt;/strong&gt; une tâche précise (résumer, expliquer, reformuler), jamais « fais tout mon travail ».</a:t>
+            </a:r>
+          </a:p>
+          <a:p>
+            <a:pPr>
+              <a:defRPr sz="2000"/>
+            </a:pPr>
+            <a:r>
+              <a:t>&lt;strong&gt;✅ Donnez du contexte :&lt;/strong&gt; matière, niveau, objectif, format attendu et longueur.</a:t>
+            </a:r>
+          </a:p>
+          <a:p>
+            <a:pPr>
+              <a:defRPr sz="2000"/>
+            </a:pPr>
+            <a:r>
+              <a:t>&lt;strong&gt;✅ Vérifiez systématiquement :&lt;/strong&gt; chaque date, chiffre et référence doit être confirmé dans ton cours.</a:t>
+            </a:r>
+          </a:p>
+          <a:p>
+            <a:pPr>
+              <a:defRPr sz="2000"/>
+            </a:pPr>
+            <a:r>
+              <a:t>&lt;strong&gt;✅ Demandez la méthode :&lt;/strong&gt; « explique comment tu arrives à cette conclusion » pour apprendre, pas seulement subir.</a:t>
+            </a:r>
+          </a:p>
+          <a:p/>
+          <a:p>
+            <a:pPr>
+              <a:defRPr sz="1300" i="1">
+                <a:solidFill>
+                  <a:srgbClr val="78899C"/>
+                </a:solidFill>
+              </a:defRPr>
+            </a:pPr>
+            <a:r>
+              <a:t>English summary:</a:t>
+            </a:r>
+          </a:p>
+          <a:p>
+            <a:pPr lvl="1">
+              <a:defRPr sz="1300">
+                <a:solidFill>
+                  <a:srgbClr val="546E7A"/>
+                </a:solidFill>
+              </a:defRPr>
+            </a:pPr>
+            <a:r>
+              <a:t>• From the very first session, remember the key idea: AI is only as good as the question you ask, and the answer is only as good as your verification. Used this way, it becomes a personal tutor available 24/7 — never a substitute for your memory.</a:t>
+            </a:r>
+          </a:p>
+          <a:p>
+            <a:pPr lvl="1">
+              <a:defRPr sz="1300">
+                <a:solidFill>
+                  <a:srgbClr val="546E7A"/>
+                </a:solidFill>
+              </a:defRPr>
+            </a:pPr>
+            <a:r>
+              <a:t>• &lt;strong&gt;✅ Start small:&lt;/strong&gt; one precise task (summarise, explain, rephrase), never "do all my work".</a:t>
+            </a:r>
+          </a:p>
+          <a:p>
+            <a:pPr lvl="1">
+              <a:defRPr sz="1300">
+                <a:solidFill>
+                  <a:srgbClr val="546E7A"/>
+                </a:solidFill>
+              </a:defRPr>
+            </a:pPr>
+            <a:r>
+              <a:t>• &lt;strong&gt;✅ Give context:&lt;/strong&gt; subject, level, goal, expected format and length.</a:t>
+            </a:r>
+          </a:p>
+          <a:p>
+            <a:pPr lvl="1">
+              <a:defRPr sz="1300">
+                <a:solidFill>
+                  <a:srgbClr val="546E7A"/>
+                </a:solidFill>
+              </a:defRPr>
+            </a:pPr>
+            <a:r>
+              <a:t>• &lt;strong&gt;✅ Check systematically:&lt;/strong&gt; every date, figure and reference must be confirmed in your lesson.</a:t>
             </a:r>
           </a:p>
         </p:txBody>

</xml_diff>

<commit_message>
feat(ia-pep-2): refonte pilote S01 FAIRE avant SAVOIR
</commit_message>
<xml_diff>
--- a/ia-pep-2/seance-01/presentation.pptx
+++ b/ia-pep-2/seance-01/presentation.pptx
@@ -19,7 +19,6 @@
     <p:sldId id="267" r:id="rId18"/>
     <p:sldId id="268" r:id="rId19"/>
     <p:sldId id="269" r:id="rId20"/>
-    <p:sldId id="270" r:id="rId21"/>
   </p:sldIdLst>
   <p:sldSz cx="12191695" cy="6858000" type="screen4x3"/>
   <p:notesSz cx="6858000" cy="9144000"/>
@@ -3352,10 +3351,10 @@
           <a:lstStyle/>
           <a:p>
             <a:r>
-              <a:t>✏️ Exercice guidé (15 min)</a:t>
-            </a:r>
-            <a:r>
-              <a:t>  ·  Guided exercise</a:t>
+              <a:t>🧠 Fiche de synthèse — points clés</a:t>
+            </a:r>
+            <a:r>
+              <a:t>  ·  Summary sheet</a:t>
             </a:r>
           </a:p>
         </p:txBody>
@@ -3379,31 +3378,39 @@
               <a:defRPr sz="2000"/>
             </a:pPr>
             <a:r>
-              <a:t>Classe les 6 affirmations suivantes en Vrai (V) ou Faux (F), puis justifie en une ligne : 1) L'IA pense comme un humain. 2) L'IA a été entraînée sur des textes. 3) L'IA donne toujours des bonnes réponses. 4) L'IA peut inventer une référence. 5) L'IA remplace le professeur. 6) L'IA peut t'aider à réviser si tu vérifies.</a:t>
-            </a:r>
-          </a:p>
-          <a:p>
-            <a:pPr>
-              <a:defRPr sz="2000"/>
-            </a:pPr>
-            <a:r>
-              <a:t>—</a:t>
-            </a:r>
-          </a:p>
-          <a:p>
-            <a:pPr>
-              <a:defRPr sz="2000"/>
-            </a:pPr>
-            <a:r>
-              <a:t>▶ Solution :</a:t>
-            </a:r>
-          </a:p>
-          <a:p>
-            <a:pPr>
-              <a:defRPr sz="2000"/>
-            </a:pPr>
-            <a:r>
-              <a:t>1) F — l'IA calcule des probabilités, elle n'a ni conscience ni pensées. 2) V — c'est son apprentissage. 3) F — elle peut se tromper et même inventer (halluciner). 4) V — c'est très fréquent, d'où la règle « vérifie ». 5) F — elle assiste l'étudiant, l'évaluation et le dialogue restent humains. 6) V — à condition de vérifier le contenu avec ton cours et tes sources.</a:t>
+              <a:t>J'ai ouvert un chatbot et posé 2 vraies questions (prompts 1 et 2).</a:t>
+            </a:r>
+          </a:p>
+          <a:p>
+            <a:pPr>
+              <a:defRPr sz="2000"/>
+            </a:pPr>
+            <a:r>
+              <a:t>Je sais juger une réponse : 1 chose claire + 1 chose confuse ou douteuse.</a:t>
+            </a:r>
+          </a:p>
+          <a:p>
+            <a:pPr>
+              <a:defRPr sz="2000"/>
+            </a:pPr>
+            <a:r>
+              <a:t>Je connais les 3 erreurs qui tuent un bon usage (vague, confiance aveugle, zéro réflexion).</a:t>
+            </a:r>
+          </a:p>
+          <a:p>
+            <a:pPr>
+              <a:defRPr sz="2000"/>
+            </a:pPr>
+            <a:r>
+              <a:t>J'ai produit ma fiche d'usage : prompts + réponses + avis en 3 lignes.</a:t>
+            </a:r>
+          </a:p>
+          <a:p>
+            <a:pPr>
+              <a:defRPr sz="2000"/>
+            </a:pPr>
+            <a:r>
+              <a:t>3 règles d'or : vérifier, citer, garder ton jugement.</a:t>
             </a:r>
           </a:p>
           <a:p/>
@@ -3428,7 +3435,7 @@
               </a:defRPr>
             </a:pPr>
             <a:r>
-              <a:t>• Classify the 6 statements as True (T) or False (F), then justify in one line: 1) AI thinks like a human. 2) AI was trained on texts. 3) AI always gives good answers. 4) AI can invent a reference. 5) AI replaces the teacher. 6) AI can help you revise if you check.</a:t>
+              <a:t>• I opened a chatbot and asked 2 real questions (prompts 1 and 2).</a:t>
             </a:r>
           </a:p>
           <a:p>
@@ -3440,7 +3447,19 @@
               </a:defRPr>
             </a:pPr>
             <a:r>
-              <a:t>• 1) F — AI computes probabilities; it has neither consciousness nor thoughts. 2) T — that is its training. 3) F — it can err and even invent (hallucinate). 4) T — very common, hence the "verify" rule. 5) F — it assists the student; assessment and dialogue remain human. 6) T — provided you check the content against your lesson and sources.</a:t>
+              <a:t>• I can judge an answer: 1 clear + 1 confusing or doubtful thing.</a:t>
+            </a:r>
+          </a:p>
+          <a:p>
+            <a:pPr lvl="1">
+              <a:defRPr sz="1300">
+                <a:solidFill>
+                  <a:srgbClr val="546E7A"/>
+                </a:solidFill>
+              </a:defRPr>
+            </a:pPr>
+            <a:r>
+              <a:t>• I know the 3 mistakes killing good use (vague, blind trust, zero thinking).</a:t>
             </a:r>
           </a:p>
         </p:txBody>
@@ -3479,10 +3498,10 @@
           <a:lstStyle/>
           <a:p>
             <a:r>
-              <a:t>🧠 Fiche de synthèse — points clés</a:t>
-            </a:r>
-            <a:r>
-              <a:t>  ·  Summary sheet</a:t>
+              <a:t>🧠 Quiz éclair (3 questions)</a:t>
+            </a:r>
+            <a:r>
+              <a:t>  ·  Quick quiz</a:t>
             </a:r>
           </a:p>
         </p:txBody>
@@ -3506,39 +3525,35 @@
               <a:defRPr sz="2000"/>
             </a:pPr>
             <a:r>
-              <a:t>L'IA est un programme qui apprend à partir d'exemples pour imiter des capacités humaines.</a:t>
-            </a:r>
-          </a:p>
-          <a:p>
-            <a:pPr>
-              <a:defRPr sz="2000"/>
-            </a:pPr>
-            <a:r>
-              <a:t>Un chatbot est une machine à prédire le mot suivant, entraînée à être convaincante — pas vraie.</a:t>
-            </a:r>
-          </a:p>
-          <a:p>
-            <a:pPr>
-              <a:defRPr sz="2000"/>
-            </a:pPr>
-            <a:r>
-              <a:t>Hallucination = invention confiante. C'est fréquent, pas un bug.</a:t>
-            </a:r>
-          </a:p>
-          <a:p>
-            <a:pPr>
-              <a:defRPr sz="2000"/>
-            </a:pPr>
-            <a:r>
-              <a:t>3 familles : IA faible (tout ce qu'on utilise), générale (future), super-IA (films).</a:t>
-            </a:r>
-          </a:p>
-          <a:p>
-            <a:pPr>
-              <a:defRPr sz="2000"/>
-            </a:pPr>
-            <a:r>
-              <a:t>3 règles d'or : vérifier, citer, garder ton jugement.</a:t>
+              <a:t>Q1. Comment un chatbot produit-il sa réponse ?</a:t>
+            </a:r>
+            <a:br/>
+            <a:r>
+              <a:t>   ✅ Il prédit le mot le plus probable, mot après mot</a:t>
+            </a:r>
+          </a:p>
+          <a:p>
+            <a:pPr>
+              <a:defRPr sz="2000"/>
+            </a:pPr>
+            <a:r>
+              <a:t>Q2. Qu'est-ce qu'une « hallucination » d'IA ?</a:t>
+            </a:r>
+            <a:br/>
+            <a:r>
+              <a:t>   ✅ Une information inventée dite avec assurance</a:t>
+            </a:r>
+          </a:p>
+          <a:p>
+            <a:pPr>
+              <a:defRPr sz="2000"/>
+            </a:pPr>
+            <a:r>
+              <a:t>Q3. ChatGPT, aujourd'hui, c'est…</a:t>
+            </a:r>
+            <a:br/>
+            <a:r>
+              <a:t>   ✅ Une IA faible (étroite)</a:t>
             </a:r>
           </a:p>
           <a:p/>
@@ -3563,7 +3578,7 @@
               </a:defRPr>
             </a:pPr>
             <a:r>
-              <a:t>• AI is a program that learns from examples to imitate human abilities.</a:t>
+              <a:t>• How does a chatbot produce its answer?</a:t>
             </a:r>
           </a:p>
           <a:p>
@@ -3575,7 +3590,7 @@
               </a:defRPr>
             </a:pPr>
             <a:r>
-              <a:t>• A chatbot is a next-word prediction machine, trained to be convincing — not true.</a:t>
+              <a:t>• What is an AI "hallucination"?</a:t>
             </a:r>
           </a:p>
           <a:p>
@@ -3587,7 +3602,7 @@
               </a:defRPr>
             </a:pPr>
             <a:r>
-              <a:t>• Hallucination = confident invention. It is common, not a bug.</a:t>
+              <a:t>• ChatGPT, today, is…</a:t>
             </a:r>
           </a:p>
         </p:txBody>
@@ -3626,10 +3641,10 @@
           <a:lstStyle/>
           <a:p>
             <a:r>
-              <a:t>🧠 Quiz éclair (3 questions)</a:t>
-            </a:r>
-            <a:r>
-              <a:t>  ·  Quick quiz</a:t>
+              <a:t>À retenir</a:t>
+            </a:r>
+            <a:r>
+              <a:t>  ·  Key takeaways</a:t>
             </a:r>
           </a:p>
         </p:txBody>
@@ -3653,35 +3668,39 @@
               <a:defRPr sz="2000"/>
             </a:pPr>
             <a:r>
-              <a:t>Q1. Comment un chatbot produit-il sa réponse ?</a:t>
-            </a:r>
-            <a:br/>
-            <a:r>
-              <a:t>   ✅ Il prédit le mot le plus probable, mot après mot</a:t>
-            </a:r>
-          </a:p>
-          <a:p>
-            <a:pPr>
-              <a:defRPr sz="2000"/>
-            </a:pPr>
-            <a:r>
-              <a:t>Q2. Qu'est-ce qu'une « hallucination » d'IA ?</a:t>
-            </a:r>
-            <a:br/>
-            <a:r>
-              <a:t>   ✅ Une information inventée dite avec assurance</a:t>
-            </a:r>
-          </a:p>
-          <a:p>
-            <a:pPr>
-              <a:defRPr sz="2000"/>
-            </a:pPr>
-            <a:r>
-              <a:t>Q3. ChatGPT, aujourd'hui, c'est…</a:t>
-            </a:r>
-            <a:br/>
-            <a:r>
-              <a:t>   ✅ Une IA faible (étroite)</a:t>
+              <a:t>L'IA = programme qui apprend à partir d'exemples pour imiter des capacités humaines.</a:t>
+            </a:r>
+          </a:p>
+          <a:p>
+            <a:pPr>
+              <a:defRPr sz="2000"/>
+            </a:pPr>
+            <a:r>
+              <a:t>Un chatbot prédit le mot suivant ; il peut être convaincant sans être vrai. Hallucinations : fréquentes.</a:t>
+            </a:r>
+          </a:p>
+          <a:p>
+            <a:pPr>
+              <a:defRPr sz="2000"/>
+            </a:pPr>
+            <a:r>
+              <a:t>5 usages pour tes études : rechercher, résumer, rédiger, réviser, organiser.</a:t>
+            </a:r>
+          </a:p>
+          <a:p>
+            <a:pPr>
+              <a:defRPr sz="2000"/>
+            </a:pPr>
+            <a:r>
+              <a:t>L'IA ne pense pas, ne ressent pas, n'apprend rien à ta place : la compréhension reste ton travail.</a:t>
+            </a:r>
+          </a:p>
+          <a:p>
+            <a:pPr>
+              <a:defRPr sz="2000"/>
+            </a:pPr>
+            <a:r>
+              <a:t>3 règles d'or : vérifier, citer, garder ton jugement.</a:t>
             </a:r>
           </a:p>
           <a:p/>
@@ -3706,7 +3725,7 @@
               </a:defRPr>
             </a:pPr>
             <a:r>
-              <a:t>• How does a chatbot produce its answer?</a:t>
+              <a:t>• AI = a program that learns from examples to imitate human abilities.</a:t>
             </a:r>
           </a:p>
           <a:p>
@@ -3718,7 +3737,7 @@
               </a:defRPr>
             </a:pPr>
             <a:r>
-              <a:t>• What is an AI "hallucination"?</a:t>
+              <a:t>• A chatbot predicts the next word; it can be convincing without being true. Hallucinations: common.</a:t>
             </a:r>
           </a:p>
           <a:p>
@@ -3730,7 +3749,31 @@
               </a:defRPr>
             </a:pPr>
             <a:r>
-              <a:t>• ChatGPT, today, is…</a:t>
+              <a:t>• 5 uses for your studies: search, summarise, write, revise, organise.</a:t>
+            </a:r>
+          </a:p>
+          <a:p>
+            <a:pPr lvl="1">
+              <a:defRPr sz="1300">
+                <a:solidFill>
+                  <a:srgbClr val="546E7A"/>
+                </a:solidFill>
+              </a:defRPr>
+            </a:pPr>
+            <a:r>
+              <a:t>• AI does not think, does not feel, learns nothing for you: understanding remains your work.</a:t>
+            </a:r>
+          </a:p>
+          <a:p>
+            <a:pPr lvl="1">
+              <a:defRPr sz="1300">
+                <a:solidFill>
+                  <a:srgbClr val="546E7A"/>
+                </a:solidFill>
+              </a:defRPr>
+            </a:pPr>
+            <a:r>
+              <a:t>• 3 golden rules: verify, cite, keep your judgement.</a:t>
             </a:r>
           </a:p>
         </p:txBody>
@@ -3744,177 +3787,6 @@
 </file>
 
 <file path=ppt/slides/slide14.xml><?xml version="1.0" encoding="utf-8"?>
-<p:sld xmlns:a="http://schemas.openxmlformats.org/drawingml/2006/main" xmlns:p="http://schemas.openxmlformats.org/presentationml/2006/main" xmlns:r="http://schemas.openxmlformats.org/officeDocument/2006/relationships">
-  <p:cSld>
-    <p:spTree>
-      <p:nvGrpSpPr>
-        <p:cNvPr id="1" name=""/>
-        <p:cNvGrpSpPr/>
-        <p:nvPr/>
-      </p:nvGrpSpPr>
-      <p:grpSpPr/>
-      <p:sp>
-        <p:nvSpPr>
-          <p:cNvPr id="2" name="Title 1"/>
-          <p:cNvSpPr>
-            <a:spLocks noGrp="1"/>
-          </p:cNvSpPr>
-          <p:nvPr>
-            <p:ph type="title"/>
-          </p:nvPr>
-        </p:nvSpPr>
-        <p:spPr/>
-        <p:txBody>
-          <a:bodyPr/>
-          <a:lstStyle/>
-          <a:p>
-            <a:r>
-              <a:t>À retenir</a:t>
-            </a:r>
-            <a:r>
-              <a:t>  ·  Key takeaways</a:t>
-            </a:r>
-          </a:p>
-        </p:txBody>
-      </p:sp>
-      <p:sp>
-        <p:nvSpPr>
-          <p:cNvPr id="3" name="Content Placeholder 2"/>
-          <p:cNvSpPr>
-            <a:spLocks noGrp="1"/>
-          </p:cNvSpPr>
-          <p:nvPr>
-            <p:ph idx="1"/>
-          </p:nvPr>
-        </p:nvSpPr>
-        <p:spPr/>
-        <p:txBody>
-          <a:bodyPr wrap="square"/>
-          <a:lstStyle/>
-          <a:p>
-            <a:pPr>
-              <a:defRPr sz="2000"/>
-            </a:pPr>
-            <a:r>
-              <a:t>L'IA = programme qui apprend à partir d'exemples pour imiter des capacités humaines.</a:t>
-            </a:r>
-          </a:p>
-          <a:p>
-            <a:pPr>
-              <a:defRPr sz="2000"/>
-            </a:pPr>
-            <a:r>
-              <a:t>Un chatbot prédit le mot suivant ; il peut être convaincant sans être vrai. Hallucinations : fréquentes.</a:t>
-            </a:r>
-          </a:p>
-          <a:p>
-            <a:pPr>
-              <a:defRPr sz="2000"/>
-            </a:pPr>
-            <a:r>
-              <a:t>5 usages pour tes études : rechercher, résumer, rédiger, réviser, organiser.</a:t>
-            </a:r>
-          </a:p>
-          <a:p>
-            <a:pPr>
-              <a:defRPr sz="2000"/>
-            </a:pPr>
-            <a:r>
-              <a:t>L'IA ne pense pas, ne ressent pas, n'apprend rien à ta place : la compréhension reste ton travail.</a:t>
-            </a:r>
-          </a:p>
-          <a:p>
-            <a:pPr>
-              <a:defRPr sz="2000"/>
-            </a:pPr>
-            <a:r>
-              <a:t>3 règles d'or : vérifier, citer, garder ton jugement.</a:t>
-            </a:r>
-          </a:p>
-          <a:p/>
-          <a:p>
-            <a:pPr>
-              <a:defRPr sz="1300" i="1">
-                <a:solidFill>
-                  <a:srgbClr val="78899C"/>
-                </a:solidFill>
-              </a:defRPr>
-            </a:pPr>
-            <a:r>
-              <a:t>English summary:</a:t>
-            </a:r>
-          </a:p>
-          <a:p>
-            <a:pPr lvl="1">
-              <a:defRPr sz="1300">
-                <a:solidFill>
-                  <a:srgbClr val="546E7A"/>
-                </a:solidFill>
-              </a:defRPr>
-            </a:pPr>
-            <a:r>
-              <a:t>• AI = a program that learns from examples to imitate human abilities.</a:t>
-            </a:r>
-          </a:p>
-          <a:p>
-            <a:pPr lvl="1">
-              <a:defRPr sz="1300">
-                <a:solidFill>
-                  <a:srgbClr val="546E7A"/>
-                </a:solidFill>
-              </a:defRPr>
-            </a:pPr>
-            <a:r>
-              <a:t>• A chatbot predicts the next word; it can be convincing without being true. Hallucinations: common.</a:t>
-            </a:r>
-          </a:p>
-          <a:p>
-            <a:pPr lvl="1">
-              <a:defRPr sz="1300">
-                <a:solidFill>
-                  <a:srgbClr val="546E7A"/>
-                </a:solidFill>
-              </a:defRPr>
-            </a:pPr>
-            <a:r>
-              <a:t>• 5 uses for your studies: search, summarise, write, revise, organise.</a:t>
-            </a:r>
-          </a:p>
-          <a:p>
-            <a:pPr lvl="1">
-              <a:defRPr sz="1300">
-                <a:solidFill>
-                  <a:srgbClr val="546E7A"/>
-                </a:solidFill>
-              </a:defRPr>
-            </a:pPr>
-            <a:r>
-              <a:t>• AI does not think, does not feel, learns nothing for you: understanding remains your work.</a:t>
-            </a:r>
-          </a:p>
-          <a:p>
-            <a:pPr lvl="1">
-              <a:defRPr sz="1300">
-                <a:solidFill>
-                  <a:srgbClr val="546E7A"/>
-                </a:solidFill>
-              </a:defRPr>
-            </a:pPr>
-            <a:r>
-              <a:t>• 3 golden rules: verify, cite, keep your judgement.</a:t>
-            </a:r>
-          </a:p>
-        </p:txBody>
-      </p:sp>
-    </p:spTree>
-  </p:cSld>
-  <p:clrMapOvr>
-    <a:masterClrMapping/>
-  </p:clrMapOvr>
-</p:sld>
-</file>
-
-<file path=ppt/slides/slide15.xml><?xml version="1.0" encoding="utf-8"?>
 <p:sld xmlns:a="http://schemas.openxmlformats.org/drawingml/2006/main" xmlns:p="http://schemas.openxmlformats.org/presentationml/2006/main" xmlns:r="http://schemas.openxmlformats.org/officeDocument/2006/relationships">
   <p:cSld>
     <p:bg>
@@ -4071,31 +3943,31 @@
               <a:defRPr sz="2000"/>
             </a:pPr>
             <a:r>
-              <a:t>Définir avec tes mots : IA, modèle de langage et prompt.</a:t>
-            </a:r>
-          </a:p>
-          <a:p>
-            <a:pPr>
-              <a:defRPr sz="2000"/>
-            </a:pPr>
-            <a:r>
-              <a:t>Expliquer simplement comment un chatbot répond (il prédit le mot le plus probable à partir d'exemples).</a:t>
-            </a:r>
-          </a:p>
-          <a:p>
-            <a:pPr>
-              <a:defRPr sz="2000"/>
-            </a:pPr>
-            <a:r>
-              <a:t>Citer 5 usages de l'IA utiles à tes études (rechercher, résumer, rédiger, réviser, organiser).</a:t>
-            </a:r>
-          </a:p>
-          <a:p>
-            <a:pPr>
-              <a:defRPr sz="2000"/>
-            </a:pPr>
-            <a:r>
-              <a:t>Identifier 3 limites : erreurs, hallucinations, biais.</a:t>
+              <a:t>Ouvrir ChatGPT ou Gemini et poser ta première question avec un prompt prêt à copier.</a:t>
+            </a:r>
+          </a:p>
+          <a:p>
+            <a:pPr>
+              <a:defRPr sz="2000"/>
+            </a:pPr>
+            <a:r>
+              <a:t>Obtenir une explication simple de l'IA + 3 exemples que tu utilises sans le savoir.</a:t>
+            </a:r>
+          </a:p>
+          <a:p>
+            <a:pPr>
+              <a:defRPr sz="2000"/>
+            </a:pPr>
+            <a:r>
+              <a:t>Juger une réponse d'IA : noter ce qui est clair, confus ou douteux.</a:t>
+            </a:r>
+          </a:p>
+          <a:p>
+            <a:pPr>
+              <a:defRPr sz="2000"/>
+            </a:pPr>
+            <a:r>
+              <a:t>Expliquer l'IA en 1 phrase à un enfant de 12 ans.</a:t>
             </a:r>
           </a:p>
           <a:p>
@@ -4128,7 +4000,7 @@
               </a:defRPr>
             </a:pPr>
             <a:r>
-              <a:t>• Define in your own words: AI, language model and prompt.</a:t>
+              <a:t>• Open ChatGPT or Gemini and ask your first question with a ready-to-copy prompt.</a:t>
             </a:r>
           </a:p>
           <a:p>
@@ -4140,7 +4012,7 @@
               </a:defRPr>
             </a:pPr>
             <a:r>
-              <a:t>• Explain simply how a chatbot answers (it predicts the most probable word from examples).</a:t>
+              <a:t>• Get a simple explanation of AI + 3 examples you already use unknowingly.</a:t>
             </a:r>
           </a:p>
           <a:p>
@@ -4152,7 +4024,7 @@
               </a:defRPr>
             </a:pPr>
             <a:r>
-              <a:t>• List 5 AI uses helpful for your studies (search, summarise, write, revise, organise).</a:t>
+              <a:t>• Judge an AI answer: note what is clear, confusing or doubtful.</a:t>
             </a:r>
           </a:p>
           <a:p>
@@ -4164,7 +4036,7 @@
               </a:defRPr>
             </a:pPr>
             <a:r>
-              <a:t>• Identify 3 limits: errors, hallucinations, biases.</a:t>
+              <a:t>• Explain AI in 1 sentence to a 12-year-old.</a:t>
             </a:r>
           </a:p>
           <a:p>
@@ -4242,47 +4114,47 @@
               <a:defRPr sz="2000"/>
             </a:pPr>
             <a:r>
-              <a:t>00–05 — Accroche et sondage</a:t>
-            </a:r>
-          </a:p>
-          <a:p>
-            <a:pPr>
-              <a:defRPr sz="2000"/>
-            </a:pPr>
-            <a:r>
-              <a:t>05–20 — Explication pas à pas : 3 idées clés</a:t>
-            </a:r>
-          </a:p>
-          <a:p>
-            <a:pPr>
-              <a:defRPr sz="2000"/>
-            </a:pPr>
-            <a:r>
-              <a:t>20–40 — Démonstration : un résumé de cours</a:t>
-            </a:r>
-          </a:p>
-          <a:p>
-            <a:pPr>
-              <a:defRPr sz="2000"/>
-            </a:pPr>
-            <a:r>
-              <a:t>40–55 — Exercice guidé : vrai ou faux ?</a:t>
-            </a:r>
-          </a:p>
-          <a:p>
-            <a:pPr>
-              <a:defRPr sz="2000"/>
-            </a:pPr>
-            <a:r>
-              <a:t>55–60 — Résumé visuel et quiz éclair</a:t>
-            </a:r>
-          </a:p>
-          <a:p>
-            <a:pPr>
-              <a:defRPr sz="2000"/>
-            </a:pPr>
-            <a:r>
-              <a:t>60–90 — Atelier : dialogues et rôles</a:t>
+              <a:t>00–05 — 🚀 Action immédiate : ta première question</a:t>
+            </a:r>
+          </a:p>
+          <a:p>
+            <a:pPr>
+              <a:defRPr sz="2000"/>
+            </a:pPr>
+            <a:r>
+              <a:t>05–20 — 📋 Recette pas à pas : 2e question et comparaison</a:t>
+            </a:r>
+          </a:p>
+          <a:p>
+            <a:pPr>
+              <a:defRPr sz="2000"/>
+            </a:pPr>
+            <a:r>
+              <a:t>20–40 — 🛠️ Démo : erreurs fréquentes et 2e avis</a:t>
+            </a:r>
+          </a:p>
+          <a:p>
+            <a:pPr>
+              <a:defRPr sz="2000"/>
+            </a:pPr>
+            <a:r>
+              <a:t>40–55 — 🧪 Mission : ta première fiche d'usage</a:t>
+            </a:r>
+          </a:p>
+          <a:p>
+            <a:pPr>
+              <a:defRPr sz="2000"/>
+            </a:pPr>
+            <a:r>
+              <a:t>55–60 — ✅ Checklist et quiz éclair</a:t>
+            </a:r>
+          </a:p>
+          <a:p>
+            <a:pPr>
+              <a:defRPr sz="2000"/>
+            </a:pPr>
+            <a:r>
+              <a:t>60–90 — 🤝 Atelier : mission et dialogues</a:t>
             </a:r>
           </a:p>
           <a:p/>
@@ -4307,7 +4179,7 @@
               </a:defRPr>
             </a:pPr>
             <a:r>
-              <a:t>• Hook and survey</a:t>
+              <a:t>• 🚀 Instant action: your first question</a:t>
             </a:r>
           </a:p>
           <a:p>
@@ -4319,7 +4191,7 @@
               </a:defRPr>
             </a:pPr>
             <a:r>
-              <a:t>• Step-by-step: 3 key ideas</a:t>
+              <a:t>• 📋 Step-by-step recipe: 2nd question and comparison</a:t>
             </a:r>
           </a:p>
           <a:p>
@@ -4331,7 +4203,7 @@
               </a:defRPr>
             </a:pPr>
             <a:r>
-              <a:t>• Demonstration: a lesson summary</a:t>
+              <a:t>• 🛠️ Demo: frequent mistakes and 2nd opinion</a:t>
             </a:r>
           </a:p>
           <a:p>
@@ -4343,7 +4215,7 @@
               </a:defRPr>
             </a:pPr>
             <a:r>
-              <a:t>• Guided exercise: true or false?</a:t>
+              <a:t>• 🧪 Mission: your first usage sheet</a:t>
             </a:r>
           </a:p>
           <a:p>
@@ -4355,7 +4227,7 @@
               </a:defRPr>
             </a:pPr>
             <a:r>
-              <a:t>• Visual summary and quick quiz</a:t>
+              <a:t>• ✅ Checklist and quick quiz</a:t>
             </a:r>
           </a:p>
           <a:p>
@@ -4367,7 +4239,7 @@
               </a:defRPr>
             </a:pPr>
             <a:r>
-              <a:t>• Workshop: dialogues and role-play</a:t>
+              <a:t>• 🤝 Workshop: mission and dialogues</a:t>
             </a:r>
           </a:p>
         </p:txBody>
@@ -4406,10 +4278,10 @@
           <a:lstStyle/>
           <a:p>
             <a:r>
-              <a:t>🎬 Accroche (5 min)</a:t>
-            </a:r>
-            <a:r>
-              <a:t>  ·  Hook</a:t>
+              <a:t>🎯 Ce que vous saurez faire à la fin</a:t>
+            </a:r>
+            <a:r>
+              <a:t>  ·  🎯 What you will be able to do by the end</a:t>
             </a:r>
           </a:p>
         </p:txBody>
@@ -4433,23 +4305,31 @@
               <a:defRPr sz="2000"/>
             </a:pPr>
             <a:r>
-              <a:t>❓ Savez-vous que votre téléphone utilise l'IA des dizaines de fois par jour, sans que vous vous en rendiez compte ? Verrouillage du visage, traduction, correction du clavier, recommandation de vidéos…</a:t>
-            </a:r>
-          </a:p>
-          <a:p>
-            <a:pPr>
-              <a:defRPr sz="2000"/>
-            </a:pPr>
-            <a:r>
-              <a:t>🍳 🍳 L'IA, c'est comme un apprenti cuisinier : il goûte des milliers de plats (les exemples), remarque des régularités (le sucre c'est sucré, le citron c'est acide) et finit par pouvoir créer sa propre recette. Il ne sait pas POURQUOI ça marche, il a appris QUE ça marche.</a:t>
-            </a:r>
-          </a:p>
-          <a:p>
-            <a:pPr>
-              <a:defRPr sz="2000"/>
-            </a:pPr>
-            <a:r>
-              <a:t>💡 💡 L'IA, c'est un programme informatique qui apprend à partir d'exemples pour imiter certaines capacités humaines : comprendre, parler, traduire, voir, décider.</a:t>
+              <a:t>Pas de cours magistral : dans 10 minutes, tu auras déjà parlé à une IA. Voici les 3 résultats concrets que tu produiras pendant cette séance.</a:t>
+            </a:r>
+          </a:p>
+          <a:p>
+            <a:pPr>
+              <a:defRPr sz="2000"/>
+            </a:pPr>
+            <a:r>
+              <a:t>&lt;strong&gt;1.&lt;/strong&gt; Poser 2 questions à un chatbot (prompts prêts ci-dessous) et obtenir 2 réponses utilisables.</a:t>
+            </a:r>
+          </a:p>
+          <a:p>
+            <a:pPr>
+              <a:defRPr sz="2000"/>
+            </a:pPr>
+            <a:r>
+              <a:t>&lt;strong&gt;2.&lt;/strong&gt; Juger chaque réponse : noter 1 chose claire + 1 chose confuse ou douteuse.</a:t>
+            </a:r>
+          </a:p>
+          <a:p>
+            <a:pPr>
+              <a:defRPr sz="2000"/>
+            </a:pPr>
+            <a:r>
+              <a:t>&lt;strong&gt;3.&lt;/strong&gt; Expliquer l'IA en 1 phrase à un enfant de 12 ans — et prouver que tu as compris.</a:t>
             </a:r>
           </a:p>
           <a:p/>
@@ -4474,7 +4354,43 @@
               </a:defRPr>
             </a:pPr>
             <a:r>
-              <a:t>• 💡 AI is a computer program that learns from examples to imitate certain human abilities: understanding, speaking, translating, seeing, deciding.</a:t>
+              <a:t>• No lecture: in 10 minutes, you will already have talked to an AI. Here are the 3 concrete results you will produce during this session.</a:t>
+            </a:r>
+          </a:p>
+          <a:p>
+            <a:pPr lvl="1">
+              <a:defRPr sz="1300">
+                <a:solidFill>
+                  <a:srgbClr val="546E7A"/>
+                </a:solidFill>
+              </a:defRPr>
+            </a:pPr>
+            <a:r>
+              <a:t>• &lt;strong&gt;1.&lt;/strong&gt; Ask a chatbot 2 questions (ready prompts below) and get 2 usable answers.</a:t>
+            </a:r>
+          </a:p>
+          <a:p>
+            <a:pPr lvl="1">
+              <a:defRPr sz="1300">
+                <a:solidFill>
+                  <a:srgbClr val="546E7A"/>
+                </a:solidFill>
+              </a:defRPr>
+            </a:pPr>
+            <a:r>
+              <a:t>• &lt;strong&gt;2.&lt;/strong&gt; Judge each answer: note 1 clear + 1 confusing or doubtful thing.</a:t>
+            </a:r>
+          </a:p>
+          <a:p>
+            <a:pPr lvl="1">
+              <a:defRPr sz="1300">
+                <a:solidFill>
+                  <a:srgbClr val="546E7A"/>
+                </a:solidFill>
+              </a:defRPr>
+            </a:pPr>
+            <a:r>
+              <a:t>• &lt;strong&gt;3.&lt;/strong&gt; Explain AI in 1 sentence to a 12-year-old — proving you understood.</a:t>
             </a:r>
           </a:p>
         </p:txBody>
@@ -4513,10 +4429,10 @@
           <a:lstStyle/>
           <a:p>
             <a:r>
-              <a:t>Idée clé 1 — L'IA apprend sur des exemples</a:t>
-            </a:r>
-            <a:r>
-              <a:t>  ·  Key idea 1 — AI learns from examples</a:t>
+              <a:t>🚀 Action immédiate — ta première fois (5 minutes)</a:t>
+            </a:r>
+            <a:r>
+              <a:t>  ·  🚀 Instant action — your first time (5 minutes)</a:t>
             </a:r>
           </a:p>
         </p:txBody>
@@ -4540,31 +4456,7 @@
               <a:defRPr sz="2000"/>
             </a:pPr>
             <a:r>
-              <a:t>Une IA n'est pas programmée « à la main » comme une calculatrice. On lui montre des milliers d'exemples, et elle en tire des régularités. C'est une énorme machine à généraliser.</a:t>
-            </a:r>
-          </a:p>
-          <a:p>
-            <a:pPr>
-              <a:defRPr sz="2000"/>
-            </a:pPr>
-            <a:r>
-              <a:t>&lt;strong&gt;Données d'entraînement :&lt;/strong&gt; les exemples qu'on montre à l'IA (textes, images, sons).</a:t>
-            </a:r>
-          </a:p>
-          <a:p>
-            <a:pPr>
-              <a:defRPr sz="2000"/>
-            </a:pPr>
-            <a:r>
-              <a:t>&lt;strong&gt;Modèle :&lt;/strong&gt; le résultat de l'apprentissage — un « cerveau » numérique qui généralise à partir des exemples.</a:t>
-            </a:r>
-          </a:p>
-          <a:p>
-            <a:pPr>
-              <a:defRPr sz="2000"/>
-            </a:pPr>
-            <a:r>
-              <a:t>&lt;strong&gt;Prédiction :&lt;/strong&gt; quand tu lui poses une question, il ne « cherche » pas la réponse : il la reconstruit à partir de ce qu'il a appris.</a:t>
+              <a:t>Sors ton téléphone. Dans 5 minutes, tu auras posé ta première question à une IA. Suis les étapes, ne saute rien.</a:t>
             </a:r>
           </a:p>
           <a:p/>
@@ -4589,43 +4481,7 @@
               </a:defRPr>
             </a:pPr>
             <a:r>
-              <a:t>• AI is not hand-programmed like a calculator. We show it thousands of examples, and it extracts patterns. It is a huge generalisation machine.</a:t>
-            </a:r>
-          </a:p>
-          <a:p>
-            <a:pPr lvl="1">
-              <a:defRPr sz="1300">
-                <a:solidFill>
-                  <a:srgbClr val="546E7A"/>
-                </a:solidFill>
-              </a:defRPr>
-            </a:pPr>
-            <a:r>
-              <a:t>• &lt;strong&gt;Training data:&lt;/strong&gt; the examples shown to AI (texts, images, sounds).</a:t>
-            </a:r>
-          </a:p>
-          <a:p>
-            <a:pPr lvl="1">
-              <a:defRPr sz="1300">
-                <a:solidFill>
-                  <a:srgbClr val="546E7A"/>
-                </a:solidFill>
-              </a:defRPr>
-            </a:pPr>
-            <a:r>
-              <a:t>• &lt;strong&gt;Model:&lt;/strong&gt; the result of learning — a digital "brain" that generalises from examples.</a:t>
-            </a:r>
-          </a:p>
-          <a:p>
-            <a:pPr lvl="1">
-              <a:defRPr sz="1300">
-                <a:solidFill>
-                  <a:srgbClr val="546E7A"/>
-                </a:solidFill>
-              </a:defRPr>
-            </a:pPr>
-            <a:r>
-              <a:t>• &lt;strong&gt;Prediction:&lt;/strong&gt; when you ask a question, it does not "look up" the answer: it rebuilds it from what it learned.</a:t>
+              <a:t>• Take out your phone. In 5 minutes, you will have asked an AI your first question. Follow the steps, skip nothing.</a:t>
             </a:r>
           </a:p>
         </p:txBody>
@@ -4664,10 +4520,10 @@
           <a:lstStyle/>
           <a:p>
             <a:r>
-              <a:t>Idée clé 2 — Un chatbot prédit le mot suivant</a:t>
-            </a:r>
-            <a:r>
-              <a:t>  ·  Key idea 2 — A chatbot predicts the next word</a:t>
+              <a:t>📋 Recette pas à pas : 2e question et comparaison</a:t>
+            </a:r>
+            <a:r>
+              <a:t>  ·  📋 Step-by-step recipe: 2nd question and comparison</a:t>
             </a:r>
           </a:p>
         </p:txBody>
@@ -4691,31 +4547,7 @@
               <a:defRPr sz="2000"/>
             </a:pPr>
             <a:r>
-              <a:t>ChatGPT, Gemini ou Copilot sont des « modèles de langage » (LLM). Leur secret : ils ont été entraînés sur des milliards de phrases, et ils ont appris une seule chose — quel mot vient le plus probablement après celui-ci.</a:t>
-            </a:r>
-          </a:p>
-          <a:p>
-            <a:pPr>
-              <a:defRPr sz="2000"/>
-            </a:pPr>
-            <a:r>
-              <a:t>« Hier, je suis allé … » → le modèle propose « au marché » parce que c'est très fréquent dans ses données.</a:t>
-            </a:r>
-          </a:p>
-          <a:p>
-            <a:pPr>
-              <a:defRPr sz="2000"/>
-            </a:pPr>
-            <a:r>
-              <a:t>Il génère mot après mot, jusqu'à former une phrase entière. Résultat : un texte qui paraît très naturel.</a:t>
-            </a:r>
-          </a:p>
-          <a:p>
-            <a:pPr>
-              <a:defRPr sz="2000"/>
-            </a:pPr>
-            <a:r>
-              <a:t>Il est entraîné à être &lt;strong&gt;convaincant&lt;/strong&gt;, pas à être &lt;strong&gt;vrai&lt;/strong&gt;. D'où les erreurs et les hallucinations.</a:t>
+              <a:t>Reste dans le MÊME chat. Tu vas poser une 2e question, observer ce qui change, puis comparer avec la liste du cours.</a:t>
             </a:r>
           </a:p>
           <a:p/>
@@ -4740,43 +4572,7 @@
               </a:defRPr>
             </a:pPr>
             <a:r>
-              <a:t>• ChatGPT, Gemini or Copilot are "language models" (LLMs). Their secret: they were trained on billions of sentences, and they learned one thing — which word most probably comes after this one.</a:t>
-            </a:r>
-          </a:p>
-          <a:p>
-            <a:pPr lvl="1">
-              <a:defRPr sz="1300">
-                <a:solidFill>
-                  <a:srgbClr val="546E7A"/>
-                </a:solidFill>
-              </a:defRPr>
-            </a:pPr>
-            <a:r>
-              <a:t>• "Yesterday I went to …" → the model suggests "the market" because it is very frequent in its data.</a:t>
-            </a:r>
-          </a:p>
-          <a:p>
-            <a:pPr lvl="1">
-              <a:defRPr sz="1300">
-                <a:solidFill>
-                  <a:srgbClr val="546E7A"/>
-                </a:solidFill>
-              </a:defRPr>
-            </a:pPr>
-            <a:r>
-              <a:t>• It generates word after word, until a whole sentence forms. Result: text that looks very natural.</a:t>
-            </a:r>
-          </a:p>
-          <a:p>
-            <a:pPr lvl="1">
-              <a:defRPr sz="1300">
-                <a:solidFill>
-                  <a:srgbClr val="546E7A"/>
-                </a:solidFill>
-              </a:defRPr>
-            </a:pPr>
-            <a:r>
-              <a:t>• It is trained to be &lt;strong&gt;convincing&lt;/strong&gt;, not &lt;strong&gt;true&lt;/strong&gt;. Hence errors and hallucinations.</a:t>
+              <a:t>• Stay in the SAME chat. You will ask a 2nd question, watch what changes, then compare with the lesson list.</a:t>
             </a:r>
           </a:p>
         </p:txBody>
@@ -4815,10 +4611,10 @@
           <a:lstStyle/>
           <a:p>
             <a:r>
-              <a:t>Idée clé 3 — Trois familles d'IA</a:t>
-            </a:r>
-            <a:r>
-              <a:t>  ·  Key idea 3 — Three families of AI</a:t>
+              <a:t>⚠️ Erreurs fréquentes des débutants</a:t>
+            </a:r>
+            <a:r>
+              <a:t>  ·  ⚠️ Frequent beginner mistakes</a:t>
             </a:r>
           </a:p>
         </p:txBody>
@@ -4842,31 +4638,31 @@
               <a:defRPr sz="2000"/>
             </a:pPr>
             <a:r>
-              <a:t>Il faut savoir classer ce dont on parle : tout ce que tu utilises aujourd'hui appartient à la première famille.</a:t>
-            </a:r>
-          </a:p>
-          <a:p>
-            <a:pPr>
-              <a:defRPr sz="2000"/>
-            </a:pPr>
-            <a:r>
-              <a:t>&lt;strong&gt;1. IA faible (étroite)&lt;/strong&gt; : excellente dans UNE tâche (traduire, trier, générer du texte). → Tout ce qui existe aujourd'hui.</a:t>
-            </a:r>
-          </a:p>
-          <a:p>
-            <a:pPr>
-              <a:defRPr sz="2000"/>
-            </a:pPr>
-            <a:r>
-              <a:t>&lt;strong&gt;2. IA générale&lt;/strong&gt; : égalerait l'humain dans TOUTES les tâches. → N'existe pas encore.</a:t>
-            </a:r>
-          </a:p>
-          <a:p>
-            <a:pPr>
-              <a:defRPr sz="2000"/>
-            </a:pPr>
-            <a:r>
-              <a:t>&lt;strong&gt;3. Super-IA&lt;/strong&gt; : dépasserait l'humain. → Scénario hypothétique qui alimente les films et les débats.</a:t>
+              <a:t>Regarde ton écran : as-tu fait l'une de ces 3 erreurs ? Chacune a sa correction immédiate — teste-la tout de suite.</a:t>
+            </a:r>
+          </a:p>
+          <a:p>
+            <a:pPr>
+              <a:defRPr sz="2000"/>
+            </a:pPr>
+            <a:r>
+              <a:t>&lt;strong&gt;❌ « Explique-moi tout sur l'IA »&lt;/strong&gt; → réponse de 20 lignes inutilisable. &lt;strong&gt;✅ Dis plutôt :&lt;/strong&gt; sujet + format + pour qui (« explique X en 5 phrases pour un étudiant de 2e année »).</a:t>
+            </a:r>
+          </a:p>
+          <a:p>
+            <a:pPr>
+              <a:defRPr sz="2000"/>
+            </a:pPr>
+            <a:r>
+              <a:t>&lt;strong&gt;❌ Croire parce que ça a l'air sûr&lt;/strong&gt; → la confiance n'est pas la vérité : l'IA invente parfois (hallucination). &lt;strong&gt;✅ Vérifie&lt;/strong&gt; 1 fait avec ton cours avant de l'utiliser.</a:t>
+            </a:r>
+          </a:p>
+          <a:p>
+            <a:pPr>
+              <a:defRPr sz="2000"/>
+            </a:pPr>
+            <a:r>
+              <a:t>&lt;strong&gt;❌ Demander AVANT de réfléchir&lt;/strong&gt; → ton cerveau s'éteint. &lt;strong&gt;✅ Pense 1 minute&lt;/strong&gt;, devine la réponse, PUIS compare avec l'IA.</a:t>
             </a:r>
           </a:p>
           <a:p/>
@@ -4891,7 +4687,7 @@
               </a:defRPr>
             </a:pPr>
             <a:r>
-              <a:t>• You should know how to classify what we talk about: everything you use today belongs to the first family.</a:t>
+              <a:t>• Look at your screen: did you make one of these 3 mistakes? Each has its instant fix — try it right now.</a:t>
             </a:r>
           </a:p>
           <a:p>
@@ -4903,7 +4699,7 @@
               </a:defRPr>
             </a:pPr>
             <a:r>
-              <a:t>• &lt;strong&gt;1. Narrow AI&lt;/strong&gt;: excellent at ONE task (translating, sorting, generating text). → Everything that exists today.</a:t>
+              <a:t>• &lt;strong&gt;❌ "Explain everything about AI to me"&lt;/strong&gt; → unusable 20-line answer. &lt;strong&gt;✅ Say instead:&lt;/strong&gt; topic + format + for whom ("explain X in 5 sentences for a 2nd-year student").</a:t>
             </a:r>
           </a:p>
           <a:p>
@@ -4915,7 +4711,7 @@
               </a:defRPr>
             </a:pPr>
             <a:r>
-              <a:t>• &lt;strong&gt;2. General AI&lt;/strong&gt;: would equal humans at ALL tasks. → Does not exist yet.</a:t>
+              <a:t>• &lt;strong&gt;❌ Believing because it sounds sure&lt;/strong&gt; → confidence is not truth: AI sometimes invents (hallucination). &lt;strong&gt;✅ Check&lt;/strong&gt; 1 fact against your lesson before using it.</a:t>
             </a:r>
           </a:p>
           <a:p>
@@ -4927,7 +4723,7 @@
               </a:defRPr>
             </a:pPr>
             <a:r>
-              <a:t>• &lt;strong&gt;3. Super-intelligence&lt;/strong&gt;: would surpass humans. → Hypothetical scenario that fuels films and debates.</a:t>
+              <a:t>• &lt;strong&gt;❌ Asking BEFORE thinking&lt;/strong&gt; → your brain switches off. &lt;strong&gt;✅ Think 1 minute&lt;/strong&gt;, guess the answer, THEN compare with AI.</a:t>
             </a:r>
           </a:p>
         </p:txBody>
@@ -4966,10 +4762,10 @@
           <a:lstStyle/>
           <a:p>
             <a:r>
-              <a:t>Démonstration — un résumé de cours, du mauvais au bon prompt</a:t>
-            </a:r>
-            <a:r>
-              <a:t>  ·  Demonstration — a course summary, from bad to good prompt</a:t>
+              <a:t>🧪 Votre mission — le livrable</a:t>
+            </a:r>
+            <a:r>
+              <a:t>  ·  🧪 Your mission — the deliverable</a:t>
             </a:r>
           </a:p>
         </p:txBody>
@@ -4993,7 +4789,39 @@
               <a:defRPr sz="2000"/>
             </a:pPr>
             <a:r>
-              <a:t>Étudiant : « Je dois préparer mon exposé de psychologie de l'enfant. Je colle mon cours et je demande à l'IA de l'aider. » Regardons la différence entre une question paresseuse et une question qui guide.</a:t>
+              <a:t>En binôme, produisez UNE page (papier ou document) : c'est ce que vous rendrez au début de la séance 2.</a:t>
+            </a:r>
+          </a:p>
+          <a:p>
+            <a:pPr>
+              <a:defRPr sz="2000"/>
+            </a:pPr>
+            <a:r>
+              <a:t>&lt;strong&gt;1.&lt;/strong&gt; Les 2 prompts utilisés, copiés mot pour mot.</a:t>
+            </a:r>
+          </a:p>
+          <a:p>
+            <a:pPr>
+              <a:defRPr sz="2000"/>
+            </a:pPr>
+            <a:r>
+              <a:t>&lt;strong&gt;2.&lt;/strong&gt; Les 2 réponses, résumées en 2 phrases chacune.</a:t>
+            </a:r>
+          </a:p>
+          <a:p>
+            <a:pPr>
+              <a:defRPr sz="2000"/>
+            </a:pPr>
+            <a:r>
+              <a:t>&lt;strong&gt;3.&lt;/strong&gt; Votre avis en 3 lignes : qu'est-ce qui est clair ? utile ? douteux ?</a:t>
+            </a:r>
+          </a:p>
+          <a:p>
+            <a:pPr>
+              <a:defRPr sz="2000"/>
+            </a:pPr>
+            <a:r>
+              <a:t>&lt;strong&gt;4.&lt;/strong&gt; Votre phrase de 12 ans : « L'IA, c'est… ».</a:t>
             </a:r>
           </a:p>
           <a:p/>
@@ -5018,7 +4846,43 @@
               </a:defRPr>
             </a:pPr>
             <a:r>
-              <a:t>• Student: "I must prepare my child-psychology presentation. I paste my lesson and ask AI to help." Look at the difference between a lazy question and a guiding one.</a:t>
+              <a:t>• In pairs, produce ONE page (paper or document): you will hand it in at the start of session 2.</a:t>
+            </a:r>
+          </a:p>
+          <a:p>
+            <a:pPr lvl="1">
+              <a:defRPr sz="1300">
+                <a:solidFill>
+                  <a:srgbClr val="546E7A"/>
+                </a:solidFill>
+              </a:defRPr>
+            </a:pPr>
+            <a:r>
+              <a:t>• &lt;strong&gt;1.&lt;/strong&gt; The 2 used prompts, copied word for word.</a:t>
+            </a:r>
+          </a:p>
+          <a:p>
+            <a:pPr lvl="1">
+              <a:defRPr sz="1300">
+                <a:solidFill>
+                  <a:srgbClr val="546E7A"/>
+                </a:solidFill>
+              </a:defRPr>
+            </a:pPr>
+            <a:r>
+              <a:t>• &lt;strong&gt;2.&lt;/strong&gt; The 2 answers, summarised in 2 sentences each.</a:t>
+            </a:r>
+          </a:p>
+          <a:p>
+            <a:pPr lvl="1">
+              <a:defRPr sz="1300">
+                <a:solidFill>
+                  <a:srgbClr val="546E7A"/>
+                </a:solidFill>
+              </a:defRPr>
+            </a:pPr>
+            <a:r>
+              <a:t>• &lt;strong&gt;3.&lt;/strong&gt; Your review in 3 lines: what is clear? useful? doubtful?</a:t>
             </a:r>
           </a:p>
         </p:txBody>
@@ -5057,10 +4921,10 @@
           <a:lstStyle/>
           <a:p>
             <a:r>
-              <a:t>Comment en profiter au maximum</a:t>
-            </a:r>
-            <a:r>
-              <a:t>  ·  How to get the most out of it</a:t>
+              <a:t>✅ Checklist de validation</a:t>
+            </a:r>
+            <a:r>
+              <a:t>  ·  ✅ Validation checklist</a:t>
             </a:r>
           </a:p>
         </p:txBody>
@@ -5084,39 +4948,39 @@
               <a:defRPr sz="2000"/>
             </a:pPr>
             <a:r>
-              <a:t>Dès la première séance, retenez l'essentiel : l'IA vaut ce que vaut la question posée, et la réponse vaut ce que vaut la vérification. Utilisée ainsi, elle devient un tuteur personnel disponible 24 h/24 — jamais un remplaçant de ta mémoire.</a:t>
-            </a:r>
-          </a:p>
-          <a:p>
-            <a:pPr>
-              <a:defRPr sz="2000"/>
-            </a:pPr>
-            <a:r>
-              <a:t>&lt;strong&gt;✅ Commencez petit :&lt;/strong&gt; une tâche précise (résumer, expliquer, reformuler), jamais « fais tout mon travail ».</a:t>
-            </a:r>
-          </a:p>
-          <a:p>
-            <a:pPr>
-              <a:defRPr sz="2000"/>
-            </a:pPr>
-            <a:r>
-              <a:t>&lt;strong&gt;✅ Donnez du contexte :&lt;/strong&gt; matière, niveau, objectif, format attendu et longueur.</a:t>
-            </a:r>
-          </a:p>
-          <a:p>
-            <a:pPr>
-              <a:defRPr sz="2000"/>
-            </a:pPr>
-            <a:r>
-              <a:t>&lt;strong&gt;✅ Vérifiez systématiquement :&lt;/strong&gt; chaque date, chiffre et référence doit être confirmé dans ton cours.</a:t>
-            </a:r>
-          </a:p>
-          <a:p>
-            <a:pPr>
-              <a:defRPr sz="2000"/>
-            </a:pPr>
-            <a:r>
-              <a:t>&lt;strong&gt;✅ Demandez la méthode :&lt;/strong&gt; « explique comment tu arrives à cette conclusion » pour apprendre, pas seulement subir.</a:t>
+              <a:t>Avant de partir, coche avec ton binôme. Tout doit être coché :</a:t>
+            </a:r>
+          </a:p>
+          <a:p>
+            <a:pPr>
+              <a:defRPr sz="2000"/>
+            </a:pPr>
+            <a:r>
+              <a:t>☐ J'ai ouvert ChatGPT ou Gemini (outil ouvert, compte créé).</a:t>
+            </a:r>
+          </a:p>
+          <a:p>
+            <a:pPr>
+              <a:defRPr sz="2000"/>
+            </a:pPr>
+            <a:r>
+              <a:t>☐ J'ai posé au moins 2 questions (prompts 1 et 2 envoyés).</a:t>
+            </a:r>
+          </a:p>
+          <a:p>
+            <a:pPr>
+              <a:defRPr sz="2000"/>
+            </a:pPr>
+            <a:r>
+              <a:t>☐ J'ai obtenu un résultat utilisable (1 chose claire notée).</a:t>
+            </a:r>
+          </a:p>
+          <a:p>
+            <a:pPr>
+              <a:defRPr sz="2000"/>
+            </a:pPr>
+            <a:r>
+              <a:t>☐ J'ai identifié 1 erreur ou limite (trop long, exemple raté, doute sur un fait).</a:t>
             </a:r>
           </a:p>
           <a:p/>
@@ -5141,7 +5005,7 @@
               </a:defRPr>
             </a:pPr>
             <a:r>
-              <a:t>• From the very first session, remember the key idea: AI is only as good as the question you ask, and the answer is only as good as your verification. Used this way, it becomes a personal tutor available 24/7 — never a substitute for your memory.</a:t>
+              <a:t>• Before leaving, tick with your partner. Everything must be ticked:</a:t>
             </a:r>
           </a:p>
           <a:p>
@@ -5153,7 +5017,7 @@
               </a:defRPr>
             </a:pPr>
             <a:r>
-              <a:t>• &lt;strong&gt;✅ Start small:&lt;/strong&gt; one precise task (summarise, explain, rephrase), never "do all my work".</a:t>
+              <a:t>• ☐ I opened ChatGPT or Gemini (tool open, account created).</a:t>
             </a:r>
           </a:p>
           <a:p>
@@ -5165,7 +5029,7 @@
               </a:defRPr>
             </a:pPr>
             <a:r>
-              <a:t>• &lt;strong&gt;✅ Give context:&lt;/strong&gt; subject, level, goal, expected format and length.</a:t>
+              <a:t>• ☐ I asked at least 2 questions (prompts 1 and 2 sent).</a:t>
             </a:r>
           </a:p>
           <a:p>
@@ -5177,7 +5041,7 @@
               </a:defRPr>
             </a:pPr>
             <a:r>
-              <a:t>• &lt;strong&gt;✅ Check systematically:&lt;/strong&gt; every date, figure and reference must be confirmed in your lesson.</a:t>
+              <a:t>• ☐ I got a usable result (1 clear thing noted).</a:t>
             </a:r>
           </a:p>
         </p:txBody>

</xml_diff>